<commit_message>
Airbnb- und Hotel-Ausarbeitung: Folie Verkauf an Verwandte
Co-Authored-By: Claude Sonnet 5.5 <noreply@anthropic.com>
Claude-Session: https://claude.ai/code/session_01HJGZfxHv7bzYyqdLwg8aFJ
</commit_message>
<xml_diff>
--- a/praesentation/Neue-Mitte-Werlte_Baufeld3_Airbnb-Apartments.pptx
+++ b/praesentation/Neue-Mitte-Werlte_Baufeld3_Airbnb-Apartments.pptx
@@ -13,9 +13,10 @@
     <p:sldId id="261" r:id="rId7"/>
     <p:sldId id="262" r:id="rId8"/>
     <p:sldId id="263" r:id="rId9"/>
+    <p:sldId id="264" r:id="rId10"/>
   </p:sldIdLst>
   <p:notesMasterIdLst>
-    <p:notesMasterId r:id="rId10"/>
+    <p:notesMasterId r:id="rId11"/>
   </p:notesMasterIdLst>
   <p:sldSz cx="12192000" cy="6858000"/>
   <p:notesSz cx="6858000" cy="12192000"/>
@@ -1037,7 +1038,7 @@
           <a:p>
             <a:r>
               <a:rPr lang="en-US" dirty="0"/>
-              <a:t>Bitte mit Bauamt und Brandschutz klären, die Hinweise sind keine Rechtsberatung.</a:t>
+              <a:t>Jede Einheit mit eigenem Kredit ohne Eigenkapital. Käufer zahlen 3,3 % Zins; Preis für das Plus: nur Zinsen, ohne Tilgung. Selbstkosten enthalten Möblierung (600 €/m²).</a:t>
             </a:r>
             <a:endParaRPr lang="en-US" dirty="0"/>
           </a:p>
@@ -1125,6 +1126,94 @@
           <a:p>
             <a:r>
               <a:rPr lang="en-US" dirty="0"/>
+              <a:t>Bitte mit Bauamt und Brandschutz klären, die Hinweise sind keine Rechtsberatung.</a:t>
+            </a:r>
+            <a:endParaRPr lang="en-US" dirty="0"/>
+          </a:p>
+        </p:txBody>
+      </p:sp>
+      <p:sp>
+        <p:nvSpPr>
+          <p:cNvPr id="4" name="Slide Number Placeholder 3"/>
+          <p:cNvSpPr>
+            <a:spLocks noGrp="1"/>
+          </p:cNvSpPr>
+          <p:nvPr>
+            <p:ph type="sldNum" sz="quarter" idx="10"/>
+          </p:nvPr>
+        </p:nvSpPr>
+        <p:spPr/>
+        <p:txBody>
+          <a:bodyPr/>
+          <a:lstStyle/>
+          <a:p>
+            <a:fld id="{F7021451-1387-4CA6-816F-3879F97B5CBC}" type="slidenum">
+              <a:rPr lang="en-US"/>
+              <a:t>8</a:t>
+            </a:fld>
+            <a:endParaRPr lang="en-US"/>
+          </a:p>
+        </p:txBody>
+      </p:sp>
+    </p:spTree>
+    <p:extLst>
+      <p:ext uri="{BB962C8B-B14F-4D97-AF65-F5344CB8AC3E}">
+        <p14:creationId xmlns:p14="http://schemas.microsoft.com/office/powerpoint/2010/main" val="1024086991"/>
+      </p:ext>
+    </p:extLst>
+  </p:cSld>
+  <p:clrMapOvr>
+    <a:masterClrMapping/>
+  </p:clrMapOvr>
+</p:notes>
+</file>
+
+<file path=ppt/notesSlides/notesSlide9.xml><?xml version="1.0" encoding="utf-8"?>
+<p:notes xmlns:a="http://schemas.openxmlformats.org/drawingml/2006/main" xmlns:r="http://schemas.openxmlformats.org/officeDocument/2006/relationships" xmlns:p="http://schemas.openxmlformats.org/presentationml/2006/main">
+  <p:cSld>
+    <p:spTree>
+      <p:nvGrpSpPr>
+        <p:cNvPr id="1" name=""/>
+        <p:cNvGrpSpPr/>
+        <p:nvPr/>
+      </p:nvGrpSpPr>
+      <p:grpSpPr>
+        <a:xfrm>
+          <a:off x="0" y="0"/>
+          <a:ext cx="0" cy="0"/>
+          <a:chOff x="0" y="0"/>
+          <a:chExt cx="0" cy="0"/>
+        </a:xfrm>
+      </p:grpSpPr>
+      <p:sp>
+        <p:nvSpPr>
+          <p:cNvPr id="2" name="Slide Image Placeholder 1"/>
+          <p:cNvSpPr>
+            <a:spLocks noGrp="1" noRot="1" noChangeAspect="1"/>
+          </p:cNvSpPr>
+          <p:nvPr>
+            <p:ph type="sldImg"/>
+          </p:nvPr>
+        </p:nvSpPr>
+        <p:spPr/>
+      </p:sp>
+      <p:sp>
+        <p:nvSpPr>
+          <p:cNvPr id="3" name="Notes Placeholder 2"/>
+          <p:cNvSpPr>
+            <a:spLocks noGrp="1"/>
+          </p:cNvSpPr>
+          <p:nvPr>
+            <p:ph type="body" idx="1"/>
+          </p:nvPr>
+        </p:nvSpPr>
+        <p:spPr/>
+        <p:txBody>
+          <a:bodyPr/>
+          <a:lstStyle/>
+          <a:p>
+            <a:r>
+              <a:rPr lang="en-US" dirty="0"/>
               <a:t/>
             </a:r>
             <a:endParaRPr lang="en-US" dirty="0"/>
@@ -1148,7 +1237,7 @@
           <a:p>
             <a:fld id="{F7021451-1387-4CA6-816F-3879F97B5CBC}" type="slidenum">
               <a:rPr lang="en-US"/>
-              <a:t>8</a:t>
+              <a:t>9</a:t>
             </a:fld>
             <a:endParaRPr lang="en-US"/>
           </a:p>
@@ -10400,6 +10489,1847 @@
                 <a:ea typeface="Georgia" pitchFamily="34" charset="-122"/>
                 <a:cs typeface="Georgia" pitchFamily="34" charset="-120"/>
               </a:rPr>
+              <a:t>Verkauf an die Verwandten</a:t>
+            </a:r>
+            <a:endParaRPr lang="en-US" sz="2700" dirty="0"/>
+          </a:p>
+        </p:txBody>
+      </p:sp>
+      <p:sp>
+        <p:nvSpPr>
+          <p:cNvPr id="3" name="Zielgruppe"/>
+          <p:cNvSpPr txBox="1"/>
+          <p:nvPr/>
+        </p:nvSpPr>
+        <p:spPr>
+          <a:xfrm>
+            <a:off x="548640" y="6446520"/>
+            <a:ext cx="5486400" cy="274320"/>
+          </a:xfrm>
+          <a:prstGeom prst="rect">
+            <a:avLst/>
+          </a:prstGeom>
+          <a:noFill/>
+          <a:ln/>
+        </p:spPr>
+        <p:txBody>
+          <a:bodyPr wrap="square" lIns="0" tIns="0" rIns="0" bIns="0" rtlCol="0" anchor="ctr"/>
+          <a:lstStyle/>
+          <a:p>
+            <a:pPr indent="0" marL="0">
+              <a:buNone/>
+            </a:pPr>
+            <a:r>
+              <a:rPr lang="en-US" sz="1000" dirty="0">
+                <a:solidFill>
+                  <a:schemeClr val="accent4"/>
+                </a:solidFill>
+              </a:rPr>
+              <a:t>Ausarbeitung 1</a:t>
+            </a:r>
+            <a:endParaRPr lang="en-US" sz="1000" dirty="0"/>
+          </a:p>
+        </p:txBody>
+      </p:sp>
+      <p:graphicFrame>
+        <p:nvGraphicFramePr>
+          <p:cNvPr id="8" name="Tabelle Verkauf Verwandte"/>
+          <p:cNvGraphicFramePr>
+            <a:graphicFrameLocks noGrp="1"/>
+          </p:cNvGraphicFramePr>
+          <p:nvPr>
+            <p:extLst>
+              <p:ext uri="{D42A27DB-BD31-4B8C-83A1-F6EECF244321}">
+                <p14:modId xmlns:p14="http://schemas.microsoft.com/office/powerpoint/2010/main" val="1579011935"/>
+              </p:ext>
+            </p:extLst>
+          </p:nvPr>
+        </p:nvGraphicFramePr>
+        <p:xfrm>
+          <a:off x="548640" y="1371600"/>
+          <a:ext cx="11091672" cy="914400"/>
+        </p:xfrm>
+        <a:graphic>
+          <a:graphicData uri="http://schemas.openxmlformats.org/drawingml/2006/table">
+            <a:tbl>
+              <a:tblPr/>
+              <a:tblGrid>
+                <a:gridCol w="1554480"/>
+                <a:gridCol w="822960"/>
+                <a:gridCol w="1463040"/>
+                <a:gridCol w="1463040"/>
+                <a:gridCol w="1554480"/>
+                <a:gridCol w="1280160"/>
+                <a:gridCol w="1463040"/>
+                <a:gridCol w="1490472"/>
+              </a:tblGrid>
+              <a:tr h="548640">
+                <a:tc>
+                  <a:txBody>
+                    <a:bodyPr/>
+                    <a:lstStyle/>
+                    <a:p>
+                      <a:pPr algn="l" indent="0" marL="0">
+                        <a:buNone/>
+                      </a:pPr>
+                      <a:r>
+                        <a:rPr lang="en-US" sz="1250" b="1" dirty="0">
+                          <a:solidFill>
+                            <a:schemeClr val="bg1"/>
+                          </a:solidFill>
+                          <a:latin typeface="Arial" pitchFamily="34" charset="0"/>
+                          <a:ea typeface="Arial" pitchFamily="34" charset="-122"/>
+                          <a:cs typeface="Arial" pitchFamily="34" charset="-120"/>
+                        </a:rPr>
+                        <a:t>Einheit</a:t>
+                      </a:r>
+                      <a:endParaRPr lang="en-US" sz="1250" dirty="0">
+                        <a:latin typeface="Arial" charset="0"/>
+                        <a:ea typeface="Arial" charset="0"/>
+                        <a:cs typeface="Arial" charset="0"/>
+                      </a:endParaRPr>
+                    </a:p>
+                  </a:txBody>
+                  <a:tcPr marL="91440" marR="91440" marT="45720" marB="45720">
+                    <a:lnL w="12700" cap="flat" cmpd="sng" algn="ctr">
+                      <a:solidFill>
+                        <a:srgbClr val="FFFFFF"/>
+                      </a:solidFill>
+                      <a:prstDash val="solid"/>
+                      <a:round/>
+                      <a:headEnd type="none" w="med" len="med"/>
+                      <a:tailEnd type="none" w="med" len="med"/>
+                    </a:lnL>
+                    <a:lnR w="12700" cap="flat" cmpd="sng" algn="ctr">
+                      <a:solidFill>
+                        <a:srgbClr val="FFFFFF"/>
+                      </a:solidFill>
+                      <a:prstDash val="solid"/>
+                      <a:round/>
+                      <a:headEnd type="none" w="med" len="med"/>
+                      <a:tailEnd type="none" w="med" len="med"/>
+                    </a:lnR>
+                    <a:lnT w="12700" cap="flat" cmpd="sng" algn="ctr">
+                      <a:solidFill>
+                        <a:srgbClr val="FFFFFF"/>
+                      </a:solidFill>
+                      <a:prstDash val="solid"/>
+                      <a:round/>
+                      <a:headEnd type="none" w="med" len="med"/>
+                      <a:tailEnd type="none" w="med" len="med"/>
+                    </a:lnT>
+                    <a:lnB w="12700" cap="flat" cmpd="sng" algn="ctr">
+                      <a:solidFill>
+                        <a:srgbClr val="FFFFFF"/>
+                      </a:solidFill>
+                      <a:prstDash val="solid"/>
+                      <a:round/>
+                      <a:headEnd type="none" w="med" len="med"/>
+                      <a:tailEnd type="none" w="med" len="med"/>
+                    </a:lnB>
+                    <a:solidFill>
+                      <a:schemeClr val="accent2"/>
+                    </a:solidFill>
+                  </a:tcPr>
+                </a:tc>
+                <a:tc>
+                  <a:txBody>
+                    <a:bodyPr/>
+                    <a:lstStyle/>
+                    <a:p>
+                      <a:pPr algn="r" indent="0" marL="0">
+                        <a:buNone/>
+                      </a:pPr>
+                      <a:r>
+                        <a:rPr lang="en-US" sz="1250" b="1" dirty="0">
+                          <a:solidFill>
+                            <a:schemeClr val="bg1"/>
+                          </a:solidFill>
+                          <a:latin typeface="Arial" pitchFamily="34" charset="0"/>
+                          <a:ea typeface="Arial" pitchFamily="34" charset="-122"/>
+                          <a:cs typeface="Arial" pitchFamily="34" charset="-120"/>
+                        </a:rPr>
+                        <a:t>Anzahl</a:t>
+                      </a:r>
+                      <a:endParaRPr lang="en-US" sz="1250" dirty="0">
+                        <a:latin typeface="Arial" charset="0"/>
+                        <a:ea typeface="Arial" charset="0"/>
+                        <a:cs typeface="Arial" charset="0"/>
+                      </a:endParaRPr>
+                    </a:p>
+                  </a:txBody>
+                  <a:tcPr marL="91440" marR="91440" marT="45720" marB="45720">
+                    <a:lnL w="12700" cap="flat" cmpd="sng" algn="ctr">
+                      <a:solidFill>
+                        <a:srgbClr val="FFFFFF"/>
+                      </a:solidFill>
+                      <a:prstDash val="solid"/>
+                      <a:round/>
+                      <a:headEnd type="none" w="med" len="med"/>
+                      <a:tailEnd type="none" w="med" len="med"/>
+                    </a:lnL>
+                    <a:lnR w="12700" cap="flat" cmpd="sng" algn="ctr">
+                      <a:solidFill>
+                        <a:srgbClr val="FFFFFF"/>
+                      </a:solidFill>
+                      <a:prstDash val="solid"/>
+                      <a:round/>
+                      <a:headEnd type="none" w="med" len="med"/>
+                      <a:tailEnd type="none" w="med" len="med"/>
+                    </a:lnR>
+                    <a:lnT w="12700" cap="flat" cmpd="sng" algn="ctr">
+                      <a:solidFill>
+                        <a:srgbClr val="FFFFFF"/>
+                      </a:solidFill>
+                      <a:prstDash val="solid"/>
+                      <a:round/>
+                      <a:headEnd type="none" w="med" len="med"/>
+                      <a:tailEnd type="none" w="med" len="med"/>
+                    </a:lnT>
+                    <a:lnB w="12700" cap="flat" cmpd="sng" algn="ctr">
+                      <a:solidFill>
+                        <a:srgbClr val="FFFFFF"/>
+                      </a:solidFill>
+                      <a:prstDash val="solid"/>
+                      <a:round/>
+                      <a:headEnd type="none" w="med" len="med"/>
+                      <a:tailEnd type="none" w="med" len="med"/>
+                    </a:lnB>
+                    <a:solidFill>
+                      <a:schemeClr val="accent2"/>
+                    </a:solidFill>
+                  </a:tcPr>
+                </a:tc>
+                <a:tc>
+                  <a:txBody>
+                    <a:bodyPr/>
+                    <a:lstStyle/>
+                    <a:p>
+                      <a:pPr algn="r" indent="0" marL="0">
+                        <a:buNone/>
+                      </a:pPr>
+                      <a:r>
+                        <a:rPr lang="en-US" sz="1250" b="1" dirty="0">
+                          <a:solidFill>
+                            <a:schemeClr val="bg1"/>
+                          </a:solidFill>
+                          <a:latin typeface="Arial" pitchFamily="34" charset="0"/>
+                          <a:ea typeface="Arial" pitchFamily="34" charset="-122"/>
+                          <a:cs typeface="Arial" pitchFamily="34" charset="-120"/>
+                        </a:rPr>
+                        <a:t>Selbstkosten</a:t>
+                      </a:r>
+                      <a:endParaRPr lang="en-US" sz="1250" dirty="0">
+                        <a:latin typeface="Arial" charset="0"/>
+                        <a:ea typeface="Arial" charset="0"/>
+                        <a:cs typeface="Arial" charset="0"/>
+                      </a:endParaRPr>
+                    </a:p>
+                  </a:txBody>
+                  <a:tcPr marL="91440" marR="91440" marT="45720" marB="45720">
+                    <a:lnL w="12700" cap="flat" cmpd="sng" algn="ctr">
+                      <a:solidFill>
+                        <a:srgbClr val="FFFFFF"/>
+                      </a:solidFill>
+                      <a:prstDash val="solid"/>
+                      <a:round/>
+                      <a:headEnd type="none" w="med" len="med"/>
+                      <a:tailEnd type="none" w="med" len="med"/>
+                    </a:lnL>
+                    <a:lnR w="12700" cap="flat" cmpd="sng" algn="ctr">
+                      <a:solidFill>
+                        <a:srgbClr val="FFFFFF"/>
+                      </a:solidFill>
+                      <a:prstDash val="solid"/>
+                      <a:round/>
+                      <a:headEnd type="none" w="med" len="med"/>
+                      <a:tailEnd type="none" w="med" len="med"/>
+                    </a:lnR>
+                    <a:lnT w="12700" cap="flat" cmpd="sng" algn="ctr">
+                      <a:solidFill>
+                        <a:srgbClr val="FFFFFF"/>
+                      </a:solidFill>
+                      <a:prstDash val="solid"/>
+                      <a:round/>
+                      <a:headEnd type="none" w="med" len="med"/>
+                      <a:tailEnd type="none" w="med" len="med"/>
+                    </a:lnT>
+                    <a:lnB w="12700" cap="flat" cmpd="sng" algn="ctr">
+                      <a:solidFill>
+                        <a:srgbClr val="FFFFFF"/>
+                      </a:solidFill>
+                      <a:prstDash val="solid"/>
+                      <a:round/>
+                      <a:headEnd type="none" w="med" len="med"/>
+                      <a:tailEnd type="none" w="med" len="med"/>
+                    </a:lnB>
+                    <a:solidFill>
+                      <a:schemeClr val="accent2"/>
+                    </a:solidFill>
+                  </a:tcPr>
+                </a:tc>
+                <a:tc>
+                  <a:txBody>
+                    <a:bodyPr/>
+                    <a:lstStyle/>
+                    <a:p>
+                      <a:pPr algn="r" indent="0" marL="0">
+                        <a:buNone/>
+                      </a:pPr>
+                      <a:r>
+                        <a:rPr lang="en-US" sz="1250" b="1" dirty="0">
+                          <a:solidFill>
+                            <a:schemeClr val="bg1"/>
+                          </a:solidFill>
+                          <a:latin typeface="Arial" pitchFamily="34" charset="0"/>
+                          <a:ea typeface="Arial" pitchFamily="34" charset="-122"/>
+                          <a:cs typeface="Arial" pitchFamily="34" charset="-120"/>
+                        </a:rPr>
+                        <a:t>Rate (1 % Tilgung)</a:t>
+                      </a:r>
+                      <a:endParaRPr lang="en-US" sz="1250" dirty="0">
+                        <a:latin typeface="Arial" charset="0"/>
+                        <a:ea typeface="Arial" charset="0"/>
+                        <a:cs typeface="Arial" charset="0"/>
+                      </a:endParaRPr>
+                    </a:p>
+                  </a:txBody>
+                  <a:tcPr marL="91440" marR="91440" marT="45720" marB="45720">
+                    <a:lnL w="12700" cap="flat" cmpd="sng" algn="ctr">
+                      <a:solidFill>
+                        <a:srgbClr val="FFFFFF"/>
+                      </a:solidFill>
+                      <a:prstDash val="solid"/>
+                      <a:round/>
+                      <a:headEnd type="none" w="med" len="med"/>
+                      <a:tailEnd type="none" w="med" len="med"/>
+                    </a:lnL>
+                    <a:lnR w="12700" cap="flat" cmpd="sng" algn="ctr">
+                      <a:solidFill>
+                        <a:srgbClr val="FFFFFF"/>
+                      </a:solidFill>
+                      <a:prstDash val="solid"/>
+                      <a:round/>
+                      <a:headEnd type="none" w="med" len="med"/>
+                      <a:tailEnd type="none" w="med" len="med"/>
+                    </a:lnR>
+                    <a:lnT w="12700" cap="flat" cmpd="sng" algn="ctr">
+                      <a:solidFill>
+                        <a:srgbClr val="FFFFFF"/>
+                      </a:solidFill>
+                      <a:prstDash val="solid"/>
+                      <a:round/>
+                      <a:headEnd type="none" w="med" len="med"/>
+                      <a:tailEnd type="none" w="med" len="med"/>
+                    </a:lnT>
+                    <a:lnB w="12700" cap="flat" cmpd="sng" algn="ctr">
+                      <a:solidFill>
+                        <a:srgbClr val="FFFFFF"/>
+                      </a:solidFill>
+                      <a:prstDash val="solid"/>
+                      <a:round/>
+                      <a:headEnd type="none" w="med" len="med"/>
+                      <a:tailEnd type="none" w="med" len="med"/>
+                    </a:lnB>
+                    <a:solidFill>
+                      <a:schemeClr val="accent2"/>
+                    </a:solidFill>
+                  </a:tcPr>
+                </a:tc>
+                <a:tc>
+                  <a:txBody>
+                    <a:bodyPr/>
+                    <a:lstStyle/>
+                    <a:p>
+                      <a:pPr algn="r" indent="0" marL="0">
+                        <a:buNone/>
+                      </a:pPr>
+                      <a:r>
+                        <a:rPr lang="en-US" sz="1250" b="1" dirty="0">
+                          <a:solidFill>
+                            <a:schemeClr val="bg1"/>
+                          </a:solidFill>
+                          <a:latin typeface="Arial" pitchFamily="34" charset="0"/>
+                          <a:ea typeface="Arial" pitchFamily="34" charset="-122"/>
+                          <a:cs typeface="Arial" pitchFamily="34" charset="-120"/>
+                        </a:rPr>
+                        <a:t>Einnahme pro Monat</a:t>
+                      </a:r>
+                      <a:endParaRPr lang="en-US" sz="1250" dirty="0">
+                        <a:latin typeface="Arial" charset="0"/>
+                        <a:ea typeface="Arial" charset="0"/>
+                        <a:cs typeface="Arial" charset="0"/>
+                      </a:endParaRPr>
+                    </a:p>
+                  </a:txBody>
+                  <a:tcPr marL="91440" marR="91440" marT="45720" marB="45720">
+                    <a:lnL w="12700" cap="flat" cmpd="sng" algn="ctr">
+                      <a:solidFill>
+                        <a:srgbClr val="FFFFFF"/>
+                      </a:solidFill>
+                      <a:prstDash val="solid"/>
+                      <a:round/>
+                      <a:headEnd type="none" w="med" len="med"/>
+                      <a:tailEnd type="none" w="med" len="med"/>
+                    </a:lnL>
+                    <a:lnR w="12700" cap="flat" cmpd="sng" algn="ctr">
+                      <a:solidFill>
+                        <a:srgbClr val="FFFFFF"/>
+                      </a:solidFill>
+                      <a:prstDash val="solid"/>
+                      <a:round/>
+                      <a:headEnd type="none" w="med" len="med"/>
+                      <a:tailEnd type="none" w="med" len="med"/>
+                    </a:lnR>
+                    <a:lnT w="12700" cap="flat" cmpd="sng" algn="ctr">
+                      <a:solidFill>
+                        <a:srgbClr val="FFFFFF"/>
+                      </a:solidFill>
+                      <a:prstDash val="solid"/>
+                      <a:round/>
+                      <a:headEnd type="none" w="med" len="med"/>
+                      <a:tailEnd type="none" w="med" len="med"/>
+                    </a:lnT>
+                    <a:lnB w="12700" cap="flat" cmpd="sng" algn="ctr">
+                      <a:solidFill>
+                        <a:srgbClr val="FFFFFF"/>
+                      </a:solidFill>
+                      <a:prstDash val="solid"/>
+                      <a:round/>
+                      <a:headEnd type="none" w="med" len="med"/>
+                      <a:tailEnd type="none" w="med" len="med"/>
+                    </a:lnB>
+                    <a:solidFill>
+                      <a:schemeClr val="accent2"/>
+                    </a:solidFill>
+                  </a:tcPr>
+                </a:tc>
+                <a:tc>
+                  <a:txBody>
+                    <a:bodyPr/>
+                    <a:lstStyle/>
+                    <a:p>
+                      <a:pPr algn="r" indent="0" marL="0">
+                        <a:buNone/>
+                      </a:pPr>
+                      <a:r>
+                        <a:rPr lang="en-US" sz="1250" b="1" dirty="0">
+                          <a:solidFill>
+                            <a:schemeClr val="bg1"/>
+                          </a:solidFill>
+                          <a:latin typeface="Arial" pitchFamily="34" charset="0"/>
+                          <a:ea typeface="Arial" pitchFamily="34" charset="-122"/>
+                          <a:cs typeface="Arial" pitchFamily="34" charset="-120"/>
+                        </a:rPr>
+                        <a:t>Ergebnis</a:t>
+                      </a:r>
+                      <a:endParaRPr lang="en-US" sz="1250" dirty="0">
+                        <a:latin typeface="Arial" charset="0"/>
+                        <a:ea typeface="Arial" charset="0"/>
+                        <a:cs typeface="Arial" charset="0"/>
+                      </a:endParaRPr>
+                    </a:p>
+                  </a:txBody>
+                  <a:tcPr marL="91440" marR="91440" marT="45720" marB="45720">
+                    <a:lnL w="12700" cap="flat" cmpd="sng" algn="ctr">
+                      <a:solidFill>
+                        <a:srgbClr val="FFFFFF"/>
+                      </a:solidFill>
+                      <a:prstDash val="solid"/>
+                      <a:round/>
+                      <a:headEnd type="none" w="med" len="med"/>
+                      <a:tailEnd type="none" w="med" len="med"/>
+                    </a:lnL>
+                    <a:lnR w="12700" cap="flat" cmpd="sng" algn="ctr">
+                      <a:solidFill>
+                        <a:srgbClr val="FFFFFF"/>
+                      </a:solidFill>
+                      <a:prstDash val="solid"/>
+                      <a:round/>
+                      <a:headEnd type="none" w="med" len="med"/>
+                      <a:tailEnd type="none" w="med" len="med"/>
+                    </a:lnR>
+                    <a:lnT w="12700" cap="flat" cmpd="sng" algn="ctr">
+                      <a:solidFill>
+                        <a:srgbClr val="FFFFFF"/>
+                      </a:solidFill>
+                      <a:prstDash val="solid"/>
+                      <a:round/>
+                      <a:headEnd type="none" w="med" len="med"/>
+                      <a:tailEnd type="none" w="med" len="med"/>
+                    </a:lnT>
+                    <a:lnB w="12700" cap="flat" cmpd="sng" algn="ctr">
+                      <a:solidFill>
+                        <a:srgbClr val="FFFFFF"/>
+                      </a:solidFill>
+                      <a:prstDash val="solid"/>
+                      <a:round/>
+                      <a:headEnd type="none" w="med" len="med"/>
+                      <a:tailEnd type="none" w="med" len="med"/>
+                    </a:lnB>
+                    <a:solidFill>
+                      <a:schemeClr val="accent2"/>
+                    </a:solidFill>
+                  </a:tcPr>
+                </a:tc>
+                <a:tc>
+                  <a:txBody>
+                    <a:bodyPr/>
+                    <a:lstStyle/>
+                    <a:p>
+                      <a:pPr algn="r" indent="0" marL="0">
+                        <a:buNone/>
+                      </a:pPr>
+                      <a:r>
+                        <a:rPr lang="en-US" sz="1250" b="1" dirty="0">
+                          <a:solidFill>
+                            <a:schemeClr val="bg1"/>
+                          </a:solidFill>
+                          <a:latin typeface="Arial" pitchFamily="34" charset="0"/>
+                          <a:ea typeface="Arial" pitchFamily="34" charset="-122"/>
+                          <a:cs typeface="Arial" pitchFamily="34" charset="-120"/>
+                        </a:rPr>
+                        <a:t>Preis für +250 €</a:t>
+                      </a:r>
+                      <a:endParaRPr lang="en-US" sz="1250" dirty="0">
+                        <a:latin typeface="Arial" charset="0"/>
+                        <a:ea typeface="Arial" charset="0"/>
+                        <a:cs typeface="Arial" charset="0"/>
+                      </a:endParaRPr>
+                    </a:p>
+                  </a:txBody>
+                  <a:tcPr marL="91440" marR="91440" marT="45720" marB="45720">
+                    <a:lnL w="12700" cap="flat" cmpd="sng" algn="ctr">
+                      <a:solidFill>
+                        <a:srgbClr val="FFFFFF"/>
+                      </a:solidFill>
+                      <a:prstDash val="solid"/>
+                      <a:round/>
+                      <a:headEnd type="none" w="med" len="med"/>
+                      <a:tailEnd type="none" w="med" len="med"/>
+                    </a:lnL>
+                    <a:lnR w="12700" cap="flat" cmpd="sng" algn="ctr">
+                      <a:solidFill>
+                        <a:srgbClr val="FFFFFF"/>
+                      </a:solidFill>
+                      <a:prstDash val="solid"/>
+                      <a:round/>
+                      <a:headEnd type="none" w="med" len="med"/>
+                      <a:tailEnd type="none" w="med" len="med"/>
+                    </a:lnR>
+                    <a:lnT w="12700" cap="flat" cmpd="sng" algn="ctr">
+                      <a:solidFill>
+                        <a:srgbClr val="FFFFFF"/>
+                      </a:solidFill>
+                      <a:prstDash val="solid"/>
+                      <a:round/>
+                      <a:headEnd type="none" w="med" len="med"/>
+                      <a:tailEnd type="none" w="med" len="med"/>
+                    </a:lnT>
+                    <a:lnB w="12700" cap="flat" cmpd="sng" algn="ctr">
+                      <a:solidFill>
+                        <a:srgbClr val="FFFFFF"/>
+                      </a:solidFill>
+                      <a:prstDash val="solid"/>
+                      <a:round/>
+                      <a:headEnd type="none" w="med" len="med"/>
+                      <a:tailEnd type="none" w="med" len="med"/>
+                    </a:lnB>
+                    <a:solidFill>
+                      <a:schemeClr val="accent2"/>
+                    </a:solidFill>
+                  </a:tcPr>
+                </a:tc>
+                <a:tc>
+                  <a:txBody>
+                    <a:bodyPr/>
+                    <a:lstStyle/>
+                    <a:p>
+                      <a:pPr algn="r" indent="0" marL="0">
+                        <a:buNone/>
+                      </a:pPr>
+                      <a:r>
+                        <a:rPr lang="en-US" sz="1250" b="1" dirty="0">
+                          <a:solidFill>
+                            <a:schemeClr val="bg1"/>
+                          </a:solidFill>
+                          <a:latin typeface="Arial" pitchFamily="34" charset="0"/>
+                          <a:ea typeface="Arial" pitchFamily="34" charset="-122"/>
+                          <a:cs typeface="Arial" pitchFamily="34" charset="-120"/>
+                        </a:rPr>
+                        <a:t>Differenz je Einheit</a:t>
+                      </a:r>
+                      <a:endParaRPr lang="en-US" sz="1250" dirty="0">
+                        <a:latin typeface="Arial" charset="0"/>
+                        <a:ea typeface="Arial" charset="0"/>
+                        <a:cs typeface="Arial" charset="0"/>
+                      </a:endParaRPr>
+                    </a:p>
+                  </a:txBody>
+                  <a:tcPr marL="91440" marR="91440" marT="45720" marB="45720">
+                    <a:lnL w="12700" cap="flat" cmpd="sng" algn="ctr">
+                      <a:solidFill>
+                        <a:srgbClr val="FFFFFF"/>
+                      </a:solidFill>
+                      <a:prstDash val="solid"/>
+                      <a:round/>
+                      <a:headEnd type="none" w="med" len="med"/>
+                      <a:tailEnd type="none" w="med" len="med"/>
+                    </a:lnL>
+                    <a:lnR w="12700" cap="flat" cmpd="sng" algn="ctr">
+                      <a:solidFill>
+                        <a:srgbClr val="FFFFFF"/>
+                      </a:solidFill>
+                      <a:prstDash val="solid"/>
+                      <a:round/>
+                      <a:headEnd type="none" w="med" len="med"/>
+                      <a:tailEnd type="none" w="med" len="med"/>
+                    </a:lnR>
+                    <a:lnT w="12700" cap="flat" cmpd="sng" algn="ctr">
+                      <a:solidFill>
+                        <a:srgbClr val="FFFFFF"/>
+                      </a:solidFill>
+                      <a:prstDash val="solid"/>
+                      <a:round/>
+                      <a:headEnd type="none" w="med" len="med"/>
+                      <a:tailEnd type="none" w="med" len="med"/>
+                    </a:lnT>
+                    <a:lnB w="12700" cap="flat" cmpd="sng" algn="ctr">
+                      <a:solidFill>
+                        <a:srgbClr val="FFFFFF"/>
+                      </a:solidFill>
+                      <a:prstDash val="solid"/>
+                      <a:round/>
+                      <a:headEnd type="none" w="med" len="med"/>
+                      <a:tailEnd type="none" w="med" len="med"/>
+                    </a:lnB>
+                    <a:solidFill>
+                      <a:schemeClr val="accent2"/>
+                    </a:solidFill>
+                  </a:tcPr>
+                </a:tc>
+              </a:tr>
+              <a:tr h="548640">
+                <a:tc>
+                  <a:txBody>
+                    <a:bodyPr/>
+                    <a:lstStyle/>
+                    <a:p>
+                      <a:pPr indent="0" marL="0">
+                        <a:buNone/>
+                      </a:pPr>
+                      <a:r>
+                        <a:rPr lang="en-US" sz="1250" dirty="0">
+                          <a:solidFill>
+                            <a:srgbClr val="000000"/>
+                          </a:solidFill>
+                          <a:latin typeface="Arial" pitchFamily="34" charset="0"/>
+                          <a:ea typeface="Arial" pitchFamily="34" charset="-122"/>
+                          <a:cs typeface="Arial" pitchFamily="34" charset="-120"/>
+                        </a:rPr>
+                        <a:t>85 m²</a:t>
+                      </a:r>
+                      <a:endParaRPr lang="en-US" sz="1250" dirty="0">
+                        <a:latin typeface="Arial" charset="0"/>
+                        <a:ea typeface="Arial" charset="0"/>
+                        <a:cs typeface="Arial" charset="0"/>
+                      </a:endParaRPr>
+                    </a:p>
+                  </a:txBody>
+                  <a:tcPr marL="91440" marR="91440" marT="45720" marB="45720">
+                    <a:lnL w="12700" cap="flat" cmpd="sng" algn="ctr">
+                      <a:solidFill>
+                        <a:srgbClr val="FFFFFF"/>
+                      </a:solidFill>
+                      <a:prstDash val="solid"/>
+                      <a:round/>
+                      <a:headEnd type="none" w="med" len="med"/>
+                      <a:tailEnd type="none" w="med" len="med"/>
+                    </a:lnL>
+                    <a:lnR w="12700" cap="flat" cmpd="sng" algn="ctr">
+                      <a:solidFill>
+                        <a:srgbClr val="FFFFFF"/>
+                      </a:solidFill>
+                      <a:prstDash val="solid"/>
+                      <a:round/>
+                      <a:headEnd type="none" w="med" len="med"/>
+                      <a:tailEnd type="none" w="med" len="med"/>
+                    </a:lnR>
+                    <a:lnT w="12700" cap="flat" cmpd="sng" algn="ctr">
+                      <a:solidFill>
+                        <a:srgbClr val="FFFFFF"/>
+                      </a:solidFill>
+                      <a:prstDash val="solid"/>
+                      <a:round/>
+                      <a:headEnd type="none" w="med" len="med"/>
+                      <a:tailEnd type="none" w="med" len="med"/>
+                    </a:lnT>
+                    <a:lnB w="12700" cap="flat" cmpd="sng" algn="ctr">
+                      <a:solidFill>
+                        <a:srgbClr val="FFFFFF"/>
+                      </a:solidFill>
+                      <a:prstDash val="solid"/>
+                      <a:round/>
+                      <a:headEnd type="none" w="med" len="med"/>
+                      <a:tailEnd type="none" w="med" len="med"/>
+                    </a:lnB>
+                  </a:tcPr>
+                </a:tc>
+                <a:tc>
+                  <a:txBody>
+                    <a:bodyPr/>
+                    <a:lstStyle/>
+                    <a:p>
+                      <a:pPr algn="r" indent="0" marL="0">
+                        <a:buNone/>
+                      </a:pPr>
+                      <a:r>
+                        <a:rPr lang="en-US" sz="1250" dirty="0">
+                          <a:solidFill>
+                            <a:srgbClr val="000000"/>
+                          </a:solidFill>
+                          <a:latin typeface="Arial" pitchFamily="34" charset="0"/>
+                          <a:ea typeface="Arial" pitchFamily="34" charset="-122"/>
+                          <a:cs typeface="Arial" pitchFamily="34" charset="-120"/>
+                        </a:rPr>
+                        <a:t>3</a:t>
+                      </a:r>
+                      <a:endParaRPr lang="en-US" sz="1250" dirty="0">
+                        <a:latin typeface="Arial" charset="0"/>
+                        <a:ea typeface="Arial" charset="0"/>
+                        <a:cs typeface="Arial" charset="0"/>
+                      </a:endParaRPr>
+                    </a:p>
+                  </a:txBody>
+                  <a:tcPr marL="91440" marR="91440" marT="45720" marB="45720">
+                    <a:lnL w="12700" cap="flat" cmpd="sng" algn="ctr">
+                      <a:solidFill>
+                        <a:srgbClr val="FFFFFF"/>
+                      </a:solidFill>
+                      <a:prstDash val="solid"/>
+                      <a:round/>
+                      <a:headEnd type="none" w="med" len="med"/>
+                      <a:tailEnd type="none" w="med" len="med"/>
+                    </a:lnL>
+                    <a:lnR w="12700" cap="flat" cmpd="sng" algn="ctr">
+                      <a:solidFill>
+                        <a:srgbClr val="FFFFFF"/>
+                      </a:solidFill>
+                      <a:prstDash val="solid"/>
+                      <a:round/>
+                      <a:headEnd type="none" w="med" len="med"/>
+                      <a:tailEnd type="none" w="med" len="med"/>
+                    </a:lnR>
+                    <a:lnT w="12700" cap="flat" cmpd="sng" algn="ctr">
+                      <a:solidFill>
+                        <a:srgbClr val="FFFFFF"/>
+                      </a:solidFill>
+                      <a:prstDash val="solid"/>
+                      <a:round/>
+                      <a:headEnd type="none" w="med" len="med"/>
+                      <a:tailEnd type="none" w="med" len="med"/>
+                    </a:lnT>
+                    <a:lnB w="12700" cap="flat" cmpd="sng" algn="ctr">
+                      <a:solidFill>
+                        <a:srgbClr val="FFFFFF"/>
+                      </a:solidFill>
+                      <a:prstDash val="solid"/>
+                      <a:round/>
+                      <a:headEnd type="none" w="med" len="med"/>
+                      <a:tailEnd type="none" w="med" len="med"/>
+                    </a:lnB>
+                  </a:tcPr>
+                </a:tc>
+                <a:tc>
+                  <a:txBody>
+                    <a:bodyPr/>
+                    <a:lstStyle/>
+                    <a:p>
+                      <a:pPr algn="r" indent="0" marL="0">
+                        <a:buNone/>
+                      </a:pPr>
+                      <a:r>
+                        <a:rPr lang="en-US" sz="1250" dirty="0">
+                          <a:solidFill>
+                            <a:srgbClr val="000000"/>
+                          </a:solidFill>
+                          <a:latin typeface="Arial" pitchFamily="34" charset="0"/>
+                          <a:ea typeface="Arial" pitchFamily="34" charset="-122"/>
+                          <a:cs typeface="Arial" pitchFamily="34" charset="-120"/>
+                        </a:rPr>
+                        <a:t>366.524 €</a:t>
+                      </a:r>
+                      <a:endParaRPr lang="en-US" sz="1250" dirty="0">
+                        <a:latin typeface="Arial" charset="0"/>
+                        <a:ea typeface="Arial" charset="0"/>
+                        <a:cs typeface="Arial" charset="0"/>
+                      </a:endParaRPr>
+                    </a:p>
+                  </a:txBody>
+                  <a:tcPr marL="91440" marR="91440" marT="45720" marB="45720">
+                    <a:lnL w="12700" cap="flat" cmpd="sng" algn="ctr">
+                      <a:solidFill>
+                        <a:srgbClr val="FFFFFF"/>
+                      </a:solidFill>
+                      <a:prstDash val="solid"/>
+                      <a:round/>
+                      <a:headEnd type="none" w="med" len="med"/>
+                      <a:tailEnd type="none" w="med" len="med"/>
+                    </a:lnL>
+                    <a:lnR w="12700" cap="flat" cmpd="sng" algn="ctr">
+                      <a:solidFill>
+                        <a:srgbClr val="FFFFFF"/>
+                      </a:solidFill>
+                      <a:prstDash val="solid"/>
+                      <a:round/>
+                      <a:headEnd type="none" w="med" len="med"/>
+                      <a:tailEnd type="none" w="med" len="med"/>
+                    </a:lnR>
+                    <a:lnT w="12700" cap="flat" cmpd="sng" algn="ctr">
+                      <a:solidFill>
+                        <a:srgbClr val="FFFFFF"/>
+                      </a:solidFill>
+                      <a:prstDash val="solid"/>
+                      <a:round/>
+                      <a:headEnd type="none" w="med" len="med"/>
+                      <a:tailEnd type="none" w="med" len="med"/>
+                    </a:lnT>
+                    <a:lnB w="12700" cap="flat" cmpd="sng" algn="ctr">
+                      <a:solidFill>
+                        <a:srgbClr val="FFFFFF"/>
+                      </a:solidFill>
+                      <a:prstDash val="solid"/>
+                      <a:round/>
+                      <a:headEnd type="none" w="med" len="med"/>
+                      <a:tailEnd type="none" w="med" len="med"/>
+                    </a:lnB>
+                  </a:tcPr>
+                </a:tc>
+                <a:tc>
+                  <a:txBody>
+                    <a:bodyPr/>
+                    <a:lstStyle/>
+                    <a:p>
+                      <a:pPr algn="r" indent="0" marL="0">
+                        <a:buNone/>
+                      </a:pPr>
+                      <a:r>
+                        <a:rPr lang="en-US" sz="1250" dirty="0">
+                          <a:solidFill>
+                            <a:srgbClr val="000000"/>
+                          </a:solidFill>
+                          <a:latin typeface="Arial" pitchFamily="34" charset="0"/>
+                          <a:ea typeface="Arial" pitchFamily="34" charset="-122"/>
+                          <a:cs typeface="Arial" pitchFamily="34" charset="-120"/>
+                        </a:rPr>
+                        <a:t>1.396 €</a:t>
+                      </a:r>
+                      <a:endParaRPr lang="en-US" sz="1250" dirty="0">
+                        <a:latin typeface="Arial" charset="0"/>
+                        <a:ea typeface="Arial" charset="0"/>
+                        <a:cs typeface="Arial" charset="0"/>
+                      </a:endParaRPr>
+                    </a:p>
+                  </a:txBody>
+                  <a:tcPr marL="91440" marR="91440" marT="45720" marB="45720">
+                    <a:lnL w="12700" cap="flat" cmpd="sng" algn="ctr">
+                      <a:solidFill>
+                        <a:srgbClr val="FFFFFF"/>
+                      </a:solidFill>
+                      <a:prstDash val="solid"/>
+                      <a:round/>
+                      <a:headEnd type="none" w="med" len="med"/>
+                      <a:tailEnd type="none" w="med" len="med"/>
+                    </a:lnL>
+                    <a:lnR w="12700" cap="flat" cmpd="sng" algn="ctr">
+                      <a:solidFill>
+                        <a:srgbClr val="FFFFFF"/>
+                      </a:solidFill>
+                      <a:prstDash val="solid"/>
+                      <a:round/>
+                      <a:headEnd type="none" w="med" len="med"/>
+                      <a:tailEnd type="none" w="med" len="med"/>
+                    </a:lnR>
+                    <a:lnT w="12700" cap="flat" cmpd="sng" algn="ctr">
+                      <a:solidFill>
+                        <a:srgbClr val="FFFFFF"/>
+                      </a:solidFill>
+                      <a:prstDash val="solid"/>
+                      <a:round/>
+                      <a:headEnd type="none" w="med" len="med"/>
+                      <a:tailEnd type="none" w="med" len="med"/>
+                    </a:lnT>
+                    <a:lnB w="12700" cap="flat" cmpd="sng" algn="ctr">
+                      <a:solidFill>
+                        <a:srgbClr val="FFFFFF"/>
+                      </a:solidFill>
+                      <a:prstDash val="solid"/>
+                      <a:round/>
+                      <a:headEnd type="none" w="med" len="med"/>
+                      <a:tailEnd type="none" w="med" len="med"/>
+                    </a:lnB>
+                  </a:tcPr>
+                </a:tc>
+                <a:tc>
+                  <a:txBody>
+                    <a:bodyPr/>
+                    <a:lstStyle/>
+                    <a:p>
+                      <a:pPr algn="r" indent="0" marL="0">
+                        <a:buNone/>
+                      </a:pPr>
+                      <a:r>
+                        <a:rPr lang="en-US" sz="1250" dirty="0">
+                          <a:solidFill>
+                            <a:srgbClr val="000000"/>
+                          </a:solidFill>
+                          <a:latin typeface="Arial" pitchFamily="34" charset="0"/>
+                          <a:ea typeface="Arial" pitchFamily="34" charset="-122"/>
+                          <a:cs typeface="Arial" pitchFamily="34" charset="-120"/>
+                        </a:rPr>
+                        <a:t>602 €</a:t>
+                      </a:r>
+                      <a:endParaRPr lang="en-US" sz="1250" dirty="0">
+                        <a:latin typeface="Arial" charset="0"/>
+                        <a:ea typeface="Arial" charset="0"/>
+                        <a:cs typeface="Arial" charset="0"/>
+                      </a:endParaRPr>
+                    </a:p>
+                  </a:txBody>
+                  <a:tcPr marL="91440" marR="91440" marT="45720" marB="45720">
+                    <a:lnL w="12700" cap="flat" cmpd="sng" algn="ctr">
+                      <a:solidFill>
+                        <a:srgbClr val="FFFFFF"/>
+                      </a:solidFill>
+                      <a:prstDash val="solid"/>
+                      <a:round/>
+                      <a:headEnd type="none" w="med" len="med"/>
+                      <a:tailEnd type="none" w="med" len="med"/>
+                    </a:lnL>
+                    <a:lnR w="12700" cap="flat" cmpd="sng" algn="ctr">
+                      <a:solidFill>
+                        <a:srgbClr val="FFFFFF"/>
+                      </a:solidFill>
+                      <a:prstDash val="solid"/>
+                      <a:round/>
+                      <a:headEnd type="none" w="med" len="med"/>
+                      <a:tailEnd type="none" w="med" len="med"/>
+                    </a:lnR>
+                    <a:lnT w="12700" cap="flat" cmpd="sng" algn="ctr">
+                      <a:solidFill>
+                        <a:srgbClr val="FFFFFF"/>
+                      </a:solidFill>
+                      <a:prstDash val="solid"/>
+                      <a:round/>
+                      <a:headEnd type="none" w="med" len="med"/>
+                      <a:tailEnd type="none" w="med" len="med"/>
+                    </a:lnT>
+                    <a:lnB w="12700" cap="flat" cmpd="sng" algn="ctr">
+                      <a:solidFill>
+                        <a:srgbClr val="FFFFFF"/>
+                      </a:solidFill>
+                      <a:prstDash val="solid"/>
+                      <a:round/>
+                      <a:headEnd type="none" w="med" len="med"/>
+                      <a:tailEnd type="none" w="med" len="med"/>
+                    </a:lnB>
+                  </a:tcPr>
+                </a:tc>
+                <a:tc>
+                  <a:txBody>
+                    <a:bodyPr/>
+                    <a:lstStyle/>
+                    <a:p>
+                      <a:pPr algn="r" indent="0" marL="0">
+                        <a:buNone/>
+                      </a:pPr>
+                      <a:r>
+                        <a:rPr lang="en-US" sz="1250" b="1" dirty="0">
+                          <a:solidFill>
+                            <a:schemeClr val="accent6"/>
+                          </a:solidFill>
+                          <a:latin typeface="Arial" pitchFamily="34" charset="0"/>
+                          <a:ea typeface="Arial" pitchFamily="34" charset="-122"/>
+                          <a:cs typeface="Arial" pitchFamily="34" charset="-120"/>
+                        </a:rPr>
+                        <a:t>−794 €</a:t>
+                      </a:r>
+                      <a:endParaRPr lang="en-US" sz="1250" dirty="0">
+                        <a:latin typeface="Arial" charset="0"/>
+                        <a:ea typeface="Arial" charset="0"/>
+                        <a:cs typeface="Arial" charset="0"/>
+                      </a:endParaRPr>
+                    </a:p>
+                  </a:txBody>
+                  <a:tcPr marL="91440" marR="91440" marT="45720" marB="45720">
+                    <a:lnL w="12700" cap="flat" cmpd="sng" algn="ctr">
+                      <a:solidFill>
+                        <a:srgbClr val="FFFFFF"/>
+                      </a:solidFill>
+                      <a:prstDash val="solid"/>
+                      <a:round/>
+                      <a:headEnd type="none" w="med" len="med"/>
+                      <a:tailEnd type="none" w="med" len="med"/>
+                    </a:lnL>
+                    <a:lnR w="12700" cap="flat" cmpd="sng" algn="ctr">
+                      <a:solidFill>
+                        <a:srgbClr val="FFFFFF"/>
+                      </a:solidFill>
+                      <a:prstDash val="solid"/>
+                      <a:round/>
+                      <a:headEnd type="none" w="med" len="med"/>
+                      <a:tailEnd type="none" w="med" len="med"/>
+                    </a:lnR>
+                    <a:lnT w="12700" cap="flat" cmpd="sng" algn="ctr">
+                      <a:solidFill>
+                        <a:srgbClr val="FFFFFF"/>
+                      </a:solidFill>
+                      <a:prstDash val="solid"/>
+                      <a:round/>
+                      <a:headEnd type="none" w="med" len="med"/>
+                      <a:tailEnd type="none" w="med" len="med"/>
+                    </a:lnT>
+                    <a:lnB w="12700" cap="flat" cmpd="sng" algn="ctr">
+                      <a:solidFill>
+                        <a:srgbClr val="FFFFFF"/>
+                      </a:solidFill>
+                      <a:prstDash val="solid"/>
+                      <a:round/>
+                      <a:headEnd type="none" w="med" len="med"/>
+                      <a:tailEnd type="none" w="med" len="med"/>
+                    </a:lnB>
+                    <a:solidFill>
+                      <a:srgbClr val="F8E4E2"/>
+                    </a:solidFill>
+                  </a:tcPr>
+                </a:tc>
+                <a:tc>
+                  <a:txBody>
+                    <a:bodyPr/>
+                    <a:lstStyle/>
+                    <a:p>
+                      <a:pPr algn="r" indent="0" marL="0">
+                        <a:buNone/>
+                      </a:pPr>
+                      <a:r>
+                        <a:rPr lang="en-US" sz="1250" dirty="0">
+                          <a:solidFill>
+                            <a:srgbClr val="000000"/>
+                          </a:solidFill>
+                          <a:latin typeface="Arial" pitchFamily="34" charset="0"/>
+                          <a:ea typeface="Arial" pitchFamily="34" charset="-122"/>
+                          <a:cs typeface="Arial" pitchFamily="34" charset="-120"/>
+                        </a:rPr>
+                        <a:t>120.514 €</a:t>
+                      </a:r>
+                      <a:endParaRPr lang="en-US" sz="1250" dirty="0">
+                        <a:latin typeface="Arial" charset="0"/>
+                        <a:ea typeface="Arial" charset="0"/>
+                        <a:cs typeface="Arial" charset="0"/>
+                      </a:endParaRPr>
+                    </a:p>
+                  </a:txBody>
+                  <a:tcPr marL="91440" marR="91440" marT="45720" marB="45720">
+                    <a:lnL w="12700" cap="flat" cmpd="sng" algn="ctr">
+                      <a:solidFill>
+                        <a:srgbClr val="FFFFFF"/>
+                      </a:solidFill>
+                      <a:prstDash val="solid"/>
+                      <a:round/>
+                      <a:headEnd type="none" w="med" len="med"/>
+                      <a:tailEnd type="none" w="med" len="med"/>
+                    </a:lnL>
+                    <a:lnR w="12700" cap="flat" cmpd="sng" algn="ctr">
+                      <a:solidFill>
+                        <a:srgbClr val="FFFFFF"/>
+                      </a:solidFill>
+                      <a:prstDash val="solid"/>
+                      <a:round/>
+                      <a:headEnd type="none" w="med" len="med"/>
+                      <a:tailEnd type="none" w="med" len="med"/>
+                    </a:lnR>
+                    <a:lnT w="12700" cap="flat" cmpd="sng" algn="ctr">
+                      <a:solidFill>
+                        <a:srgbClr val="FFFFFF"/>
+                      </a:solidFill>
+                      <a:prstDash val="solid"/>
+                      <a:round/>
+                      <a:headEnd type="none" w="med" len="med"/>
+                      <a:tailEnd type="none" w="med" len="med"/>
+                    </a:lnT>
+                    <a:lnB w="12700" cap="flat" cmpd="sng" algn="ctr">
+                      <a:solidFill>
+                        <a:srgbClr val="FFFFFF"/>
+                      </a:solidFill>
+                      <a:prstDash val="solid"/>
+                      <a:round/>
+                      <a:headEnd type="none" w="med" len="med"/>
+                      <a:tailEnd type="none" w="med" len="med"/>
+                    </a:lnB>
+                  </a:tcPr>
+                </a:tc>
+                <a:tc>
+                  <a:txBody>
+                    <a:bodyPr/>
+                    <a:lstStyle/>
+                    <a:p>
+                      <a:pPr algn="r" indent="0" marL="0">
+                        <a:buNone/>
+                      </a:pPr>
+                      <a:r>
+                        <a:rPr lang="en-US" sz="1250" dirty="0">
+                          <a:solidFill>
+                            <a:srgbClr val="000000"/>
+                          </a:solidFill>
+                          <a:latin typeface="Arial" pitchFamily="34" charset="0"/>
+                          <a:ea typeface="Arial" pitchFamily="34" charset="-122"/>
+                          <a:cs typeface="Arial" pitchFamily="34" charset="-120"/>
+                        </a:rPr>
+                        <a:t>246.010 €</a:t>
+                      </a:r>
+                      <a:endParaRPr lang="en-US" sz="1250" dirty="0">
+                        <a:latin typeface="Arial" charset="0"/>
+                        <a:ea typeface="Arial" charset="0"/>
+                        <a:cs typeface="Arial" charset="0"/>
+                      </a:endParaRPr>
+                    </a:p>
+                  </a:txBody>
+                  <a:tcPr marL="91440" marR="91440" marT="45720" marB="45720">
+                    <a:lnL w="12700" cap="flat" cmpd="sng" algn="ctr">
+                      <a:solidFill>
+                        <a:srgbClr val="FFFFFF"/>
+                      </a:solidFill>
+                      <a:prstDash val="solid"/>
+                      <a:round/>
+                      <a:headEnd type="none" w="med" len="med"/>
+                      <a:tailEnd type="none" w="med" len="med"/>
+                    </a:lnL>
+                    <a:lnR w="12700" cap="flat" cmpd="sng" algn="ctr">
+                      <a:solidFill>
+                        <a:srgbClr val="FFFFFF"/>
+                      </a:solidFill>
+                      <a:prstDash val="solid"/>
+                      <a:round/>
+                      <a:headEnd type="none" w="med" len="med"/>
+                      <a:tailEnd type="none" w="med" len="med"/>
+                    </a:lnR>
+                    <a:lnT w="12700" cap="flat" cmpd="sng" algn="ctr">
+                      <a:solidFill>
+                        <a:srgbClr val="FFFFFF"/>
+                      </a:solidFill>
+                      <a:prstDash val="solid"/>
+                      <a:round/>
+                      <a:headEnd type="none" w="med" len="med"/>
+                      <a:tailEnd type="none" w="med" len="med"/>
+                    </a:lnT>
+                    <a:lnB w="12700" cap="flat" cmpd="sng" algn="ctr">
+                      <a:solidFill>
+                        <a:srgbClr val="FFFFFF"/>
+                      </a:solidFill>
+                      <a:prstDash val="solid"/>
+                      <a:round/>
+                      <a:headEnd type="none" w="med" len="med"/>
+                      <a:tailEnd type="none" w="med" len="med"/>
+                    </a:lnB>
+                  </a:tcPr>
+                </a:tc>
+              </a:tr>
+              <a:tr h="548640">
+                <a:tc>
+                  <a:txBody>
+                    <a:bodyPr/>
+                    <a:lstStyle/>
+                    <a:p>
+                      <a:pPr indent="0" marL="0">
+                        <a:buNone/>
+                      </a:pPr>
+                      <a:r>
+                        <a:rPr lang="en-US" sz="1250" dirty="0">
+                          <a:solidFill>
+                            <a:srgbClr val="000000"/>
+                          </a:solidFill>
+                          <a:latin typeface="Arial" pitchFamily="34" charset="0"/>
+                          <a:ea typeface="Arial" pitchFamily="34" charset="-122"/>
+                          <a:cs typeface="Arial" pitchFamily="34" charset="-120"/>
+                        </a:rPr>
+                        <a:t>56 m²</a:t>
+                      </a:r>
+                      <a:endParaRPr lang="en-US" sz="1250" dirty="0">
+                        <a:latin typeface="Arial" charset="0"/>
+                        <a:ea typeface="Arial" charset="0"/>
+                        <a:cs typeface="Arial" charset="0"/>
+                      </a:endParaRPr>
+                    </a:p>
+                  </a:txBody>
+                  <a:tcPr marL="91440" marR="91440" marT="45720" marB="45720">
+                    <a:lnL w="12700" cap="flat" cmpd="sng" algn="ctr">
+                      <a:solidFill>
+                        <a:srgbClr val="FFFFFF"/>
+                      </a:solidFill>
+                      <a:prstDash val="solid"/>
+                      <a:round/>
+                      <a:headEnd type="none" w="med" len="med"/>
+                      <a:tailEnd type="none" w="med" len="med"/>
+                    </a:lnL>
+                    <a:lnR w="12700" cap="flat" cmpd="sng" algn="ctr">
+                      <a:solidFill>
+                        <a:srgbClr val="FFFFFF"/>
+                      </a:solidFill>
+                      <a:prstDash val="solid"/>
+                      <a:round/>
+                      <a:headEnd type="none" w="med" len="med"/>
+                      <a:tailEnd type="none" w="med" len="med"/>
+                    </a:lnR>
+                    <a:lnT w="12700" cap="flat" cmpd="sng" algn="ctr">
+                      <a:solidFill>
+                        <a:srgbClr val="FFFFFF"/>
+                      </a:solidFill>
+                      <a:prstDash val="solid"/>
+                      <a:round/>
+                      <a:headEnd type="none" w="med" len="med"/>
+                      <a:tailEnd type="none" w="med" len="med"/>
+                    </a:lnT>
+                    <a:lnB w="12700" cap="flat" cmpd="sng" algn="ctr">
+                      <a:solidFill>
+                        <a:srgbClr val="FFFFFF"/>
+                      </a:solidFill>
+                      <a:prstDash val="solid"/>
+                      <a:round/>
+                      <a:headEnd type="none" w="med" len="med"/>
+                      <a:tailEnd type="none" w="med" len="med"/>
+                    </a:lnB>
+                  </a:tcPr>
+                </a:tc>
+                <a:tc>
+                  <a:txBody>
+                    <a:bodyPr/>
+                    <a:lstStyle/>
+                    <a:p>
+                      <a:pPr algn="r" indent="0" marL="0">
+                        <a:buNone/>
+                      </a:pPr>
+                      <a:r>
+                        <a:rPr lang="en-US" sz="1250" dirty="0">
+                          <a:solidFill>
+                            <a:srgbClr val="000000"/>
+                          </a:solidFill>
+                          <a:latin typeface="Arial" pitchFamily="34" charset="0"/>
+                          <a:ea typeface="Arial" pitchFamily="34" charset="-122"/>
+                          <a:cs typeface="Arial" pitchFamily="34" charset="-120"/>
+                        </a:rPr>
+                        <a:t>3</a:t>
+                      </a:r>
+                      <a:endParaRPr lang="en-US" sz="1250" dirty="0">
+                        <a:latin typeface="Arial" charset="0"/>
+                        <a:ea typeface="Arial" charset="0"/>
+                        <a:cs typeface="Arial" charset="0"/>
+                      </a:endParaRPr>
+                    </a:p>
+                  </a:txBody>
+                  <a:tcPr marL="91440" marR="91440" marT="45720" marB="45720">
+                    <a:lnL w="12700" cap="flat" cmpd="sng" algn="ctr">
+                      <a:solidFill>
+                        <a:srgbClr val="FFFFFF"/>
+                      </a:solidFill>
+                      <a:prstDash val="solid"/>
+                      <a:round/>
+                      <a:headEnd type="none" w="med" len="med"/>
+                      <a:tailEnd type="none" w="med" len="med"/>
+                    </a:lnL>
+                    <a:lnR w="12700" cap="flat" cmpd="sng" algn="ctr">
+                      <a:solidFill>
+                        <a:srgbClr val="FFFFFF"/>
+                      </a:solidFill>
+                      <a:prstDash val="solid"/>
+                      <a:round/>
+                      <a:headEnd type="none" w="med" len="med"/>
+                      <a:tailEnd type="none" w="med" len="med"/>
+                    </a:lnR>
+                    <a:lnT w="12700" cap="flat" cmpd="sng" algn="ctr">
+                      <a:solidFill>
+                        <a:srgbClr val="FFFFFF"/>
+                      </a:solidFill>
+                      <a:prstDash val="solid"/>
+                      <a:round/>
+                      <a:headEnd type="none" w="med" len="med"/>
+                      <a:tailEnd type="none" w="med" len="med"/>
+                    </a:lnT>
+                    <a:lnB w="12700" cap="flat" cmpd="sng" algn="ctr">
+                      <a:solidFill>
+                        <a:srgbClr val="FFFFFF"/>
+                      </a:solidFill>
+                      <a:prstDash val="solid"/>
+                      <a:round/>
+                      <a:headEnd type="none" w="med" len="med"/>
+                      <a:tailEnd type="none" w="med" len="med"/>
+                    </a:lnB>
+                  </a:tcPr>
+                </a:tc>
+                <a:tc>
+                  <a:txBody>
+                    <a:bodyPr/>
+                    <a:lstStyle/>
+                    <a:p>
+                      <a:pPr algn="r" indent="0" marL="0">
+                        <a:buNone/>
+                      </a:pPr>
+                      <a:r>
+                        <a:rPr lang="en-US" sz="1250" dirty="0">
+                          <a:solidFill>
+                            <a:srgbClr val="000000"/>
+                          </a:solidFill>
+                          <a:latin typeface="Arial" pitchFamily="34" charset="0"/>
+                          <a:ea typeface="Arial" pitchFamily="34" charset="-122"/>
+                          <a:cs typeface="Arial" pitchFamily="34" charset="-120"/>
+                        </a:rPr>
+                        <a:t>242.795 €</a:t>
+                      </a:r>
+                      <a:endParaRPr lang="en-US" sz="1250" dirty="0">
+                        <a:latin typeface="Arial" charset="0"/>
+                        <a:ea typeface="Arial" charset="0"/>
+                        <a:cs typeface="Arial" charset="0"/>
+                      </a:endParaRPr>
+                    </a:p>
+                  </a:txBody>
+                  <a:tcPr marL="91440" marR="91440" marT="45720" marB="45720">
+                    <a:lnL w="12700" cap="flat" cmpd="sng" algn="ctr">
+                      <a:solidFill>
+                        <a:srgbClr val="FFFFFF"/>
+                      </a:solidFill>
+                      <a:prstDash val="solid"/>
+                      <a:round/>
+                      <a:headEnd type="none" w="med" len="med"/>
+                      <a:tailEnd type="none" w="med" len="med"/>
+                    </a:lnL>
+                    <a:lnR w="12700" cap="flat" cmpd="sng" algn="ctr">
+                      <a:solidFill>
+                        <a:srgbClr val="FFFFFF"/>
+                      </a:solidFill>
+                      <a:prstDash val="solid"/>
+                      <a:round/>
+                      <a:headEnd type="none" w="med" len="med"/>
+                      <a:tailEnd type="none" w="med" len="med"/>
+                    </a:lnR>
+                    <a:lnT w="12700" cap="flat" cmpd="sng" algn="ctr">
+                      <a:solidFill>
+                        <a:srgbClr val="FFFFFF"/>
+                      </a:solidFill>
+                      <a:prstDash val="solid"/>
+                      <a:round/>
+                      <a:headEnd type="none" w="med" len="med"/>
+                      <a:tailEnd type="none" w="med" len="med"/>
+                    </a:lnT>
+                    <a:lnB w="12700" cap="flat" cmpd="sng" algn="ctr">
+                      <a:solidFill>
+                        <a:srgbClr val="FFFFFF"/>
+                      </a:solidFill>
+                      <a:prstDash val="solid"/>
+                      <a:round/>
+                      <a:headEnd type="none" w="med" len="med"/>
+                      <a:tailEnd type="none" w="med" len="med"/>
+                    </a:lnB>
+                  </a:tcPr>
+                </a:tc>
+                <a:tc>
+                  <a:txBody>
+                    <a:bodyPr/>
+                    <a:lstStyle/>
+                    <a:p>
+                      <a:pPr algn="r" indent="0" marL="0">
+                        <a:buNone/>
+                      </a:pPr>
+                      <a:r>
+                        <a:rPr lang="en-US" sz="1250" dirty="0">
+                          <a:solidFill>
+                            <a:srgbClr val="000000"/>
+                          </a:solidFill>
+                          <a:latin typeface="Arial" pitchFamily="34" charset="0"/>
+                          <a:ea typeface="Arial" pitchFamily="34" charset="-122"/>
+                          <a:cs typeface="Arial" pitchFamily="34" charset="-120"/>
+                        </a:rPr>
+                        <a:t>925 €</a:t>
+                      </a:r>
+                      <a:endParaRPr lang="en-US" sz="1250" dirty="0">
+                        <a:latin typeface="Arial" charset="0"/>
+                        <a:ea typeface="Arial" charset="0"/>
+                        <a:cs typeface="Arial" charset="0"/>
+                      </a:endParaRPr>
+                    </a:p>
+                  </a:txBody>
+                  <a:tcPr marL="91440" marR="91440" marT="45720" marB="45720">
+                    <a:lnL w="12700" cap="flat" cmpd="sng" algn="ctr">
+                      <a:solidFill>
+                        <a:srgbClr val="FFFFFF"/>
+                      </a:solidFill>
+                      <a:prstDash val="solid"/>
+                      <a:round/>
+                      <a:headEnd type="none" w="med" len="med"/>
+                      <a:tailEnd type="none" w="med" len="med"/>
+                    </a:lnL>
+                    <a:lnR w="12700" cap="flat" cmpd="sng" algn="ctr">
+                      <a:solidFill>
+                        <a:srgbClr val="FFFFFF"/>
+                      </a:solidFill>
+                      <a:prstDash val="solid"/>
+                      <a:round/>
+                      <a:headEnd type="none" w="med" len="med"/>
+                      <a:tailEnd type="none" w="med" len="med"/>
+                    </a:lnR>
+                    <a:lnT w="12700" cap="flat" cmpd="sng" algn="ctr">
+                      <a:solidFill>
+                        <a:srgbClr val="FFFFFF"/>
+                      </a:solidFill>
+                      <a:prstDash val="solid"/>
+                      <a:round/>
+                      <a:headEnd type="none" w="med" len="med"/>
+                      <a:tailEnd type="none" w="med" len="med"/>
+                    </a:lnT>
+                    <a:lnB w="12700" cap="flat" cmpd="sng" algn="ctr">
+                      <a:solidFill>
+                        <a:srgbClr val="FFFFFF"/>
+                      </a:solidFill>
+                      <a:prstDash val="solid"/>
+                      <a:round/>
+                      <a:headEnd type="none" w="med" len="med"/>
+                      <a:tailEnd type="none" w="med" len="med"/>
+                    </a:lnB>
+                  </a:tcPr>
+                </a:tc>
+                <a:tc>
+                  <a:txBody>
+                    <a:bodyPr/>
+                    <a:lstStyle/>
+                    <a:p>
+                      <a:pPr algn="r" indent="0" marL="0">
+                        <a:buNone/>
+                      </a:pPr>
+                      <a:r>
+                        <a:rPr lang="en-US" sz="1250" dirty="0">
+                          <a:solidFill>
+                            <a:srgbClr val="000000"/>
+                          </a:solidFill>
+                          <a:latin typeface="Arial" pitchFamily="34" charset="0"/>
+                          <a:ea typeface="Arial" pitchFamily="34" charset="-122"/>
+                          <a:cs typeface="Arial" pitchFamily="34" charset="-120"/>
+                        </a:rPr>
+                        <a:t>512 €</a:t>
+                      </a:r>
+                      <a:endParaRPr lang="en-US" sz="1250" dirty="0">
+                        <a:latin typeface="Arial" charset="0"/>
+                        <a:ea typeface="Arial" charset="0"/>
+                        <a:cs typeface="Arial" charset="0"/>
+                      </a:endParaRPr>
+                    </a:p>
+                  </a:txBody>
+                  <a:tcPr marL="91440" marR="91440" marT="45720" marB="45720">
+                    <a:lnL w="12700" cap="flat" cmpd="sng" algn="ctr">
+                      <a:solidFill>
+                        <a:srgbClr val="FFFFFF"/>
+                      </a:solidFill>
+                      <a:prstDash val="solid"/>
+                      <a:round/>
+                      <a:headEnd type="none" w="med" len="med"/>
+                      <a:tailEnd type="none" w="med" len="med"/>
+                    </a:lnL>
+                    <a:lnR w="12700" cap="flat" cmpd="sng" algn="ctr">
+                      <a:solidFill>
+                        <a:srgbClr val="FFFFFF"/>
+                      </a:solidFill>
+                      <a:prstDash val="solid"/>
+                      <a:round/>
+                      <a:headEnd type="none" w="med" len="med"/>
+                      <a:tailEnd type="none" w="med" len="med"/>
+                    </a:lnR>
+                    <a:lnT w="12700" cap="flat" cmpd="sng" algn="ctr">
+                      <a:solidFill>
+                        <a:srgbClr val="FFFFFF"/>
+                      </a:solidFill>
+                      <a:prstDash val="solid"/>
+                      <a:round/>
+                      <a:headEnd type="none" w="med" len="med"/>
+                      <a:tailEnd type="none" w="med" len="med"/>
+                    </a:lnT>
+                    <a:lnB w="12700" cap="flat" cmpd="sng" algn="ctr">
+                      <a:solidFill>
+                        <a:srgbClr val="FFFFFF"/>
+                      </a:solidFill>
+                      <a:prstDash val="solid"/>
+                      <a:round/>
+                      <a:headEnd type="none" w="med" len="med"/>
+                      <a:tailEnd type="none" w="med" len="med"/>
+                    </a:lnB>
+                  </a:tcPr>
+                </a:tc>
+                <a:tc>
+                  <a:txBody>
+                    <a:bodyPr/>
+                    <a:lstStyle/>
+                    <a:p>
+                      <a:pPr algn="r" indent="0" marL="0">
+                        <a:buNone/>
+                      </a:pPr>
+                      <a:r>
+                        <a:rPr lang="en-US" sz="1250" b="1" dirty="0">
+                          <a:solidFill>
+                            <a:schemeClr val="accent6"/>
+                          </a:solidFill>
+                          <a:latin typeface="Arial" pitchFamily="34" charset="0"/>
+                          <a:ea typeface="Arial" pitchFamily="34" charset="-122"/>
+                          <a:cs typeface="Arial" pitchFamily="34" charset="-120"/>
+                        </a:rPr>
+                        <a:t>−413 €</a:t>
+                      </a:r>
+                      <a:endParaRPr lang="en-US" sz="1250" dirty="0">
+                        <a:latin typeface="Arial" charset="0"/>
+                        <a:ea typeface="Arial" charset="0"/>
+                        <a:cs typeface="Arial" charset="0"/>
+                      </a:endParaRPr>
+                    </a:p>
+                  </a:txBody>
+                  <a:tcPr marL="91440" marR="91440" marT="45720" marB="45720">
+                    <a:lnL w="12700" cap="flat" cmpd="sng" algn="ctr">
+                      <a:solidFill>
+                        <a:srgbClr val="FFFFFF"/>
+                      </a:solidFill>
+                      <a:prstDash val="solid"/>
+                      <a:round/>
+                      <a:headEnd type="none" w="med" len="med"/>
+                      <a:tailEnd type="none" w="med" len="med"/>
+                    </a:lnL>
+                    <a:lnR w="12700" cap="flat" cmpd="sng" algn="ctr">
+                      <a:solidFill>
+                        <a:srgbClr val="FFFFFF"/>
+                      </a:solidFill>
+                      <a:prstDash val="solid"/>
+                      <a:round/>
+                      <a:headEnd type="none" w="med" len="med"/>
+                      <a:tailEnd type="none" w="med" len="med"/>
+                    </a:lnR>
+                    <a:lnT w="12700" cap="flat" cmpd="sng" algn="ctr">
+                      <a:solidFill>
+                        <a:srgbClr val="FFFFFF"/>
+                      </a:solidFill>
+                      <a:prstDash val="solid"/>
+                      <a:round/>
+                      <a:headEnd type="none" w="med" len="med"/>
+                      <a:tailEnd type="none" w="med" len="med"/>
+                    </a:lnT>
+                    <a:lnB w="12700" cap="flat" cmpd="sng" algn="ctr">
+                      <a:solidFill>
+                        <a:srgbClr val="FFFFFF"/>
+                      </a:solidFill>
+                      <a:prstDash val="solid"/>
+                      <a:round/>
+                      <a:headEnd type="none" w="med" len="med"/>
+                      <a:tailEnd type="none" w="med" len="med"/>
+                    </a:lnB>
+                    <a:solidFill>
+                      <a:srgbClr val="F8E4E2"/>
+                    </a:solidFill>
+                  </a:tcPr>
+                </a:tc>
+                <a:tc>
+                  <a:txBody>
+                    <a:bodyPr/>
+                    <a:lstStyle/>
+                    <a:p>
+                      <a:pPr algn="r" indent="0" marL="0">
+                        <a:buNone/>
+                      </a:pPr>
+                      <a:r>
+                        <a:rPr lang="en-US" sz="1250" dirty="0">
+                          <a:solidFill>
+                            <a:srgbClr val="000000"/>
+                          </a:solidFill>
+                          <a:latin typeface="Arial" pitchFamily="34" charset="0"/>
+                          <a:ea typeface="Arial" pitchFamily="34" charset="-122"/>
+                          <a:cs typeface="Arial" pitchFamily="34" charset="-120"/>
+                        </a:rPr>
+                        <a:t>89.607 €</a:t>
+                      </a:r>
+                      <a:endParaRPr lang="en-US" sz="1250" dirty="0">
+                        <a:latin typeface="Arial" charset="0"/>
+                        <a:ea typeface="Arial" charset="0"/>
+                        <a:cs typeface="Arial" charset="0"/>
+                      </a:endParaRPr>
+                    </a:p>
+                  </a:txBody>
+                  <a:tcPr marL="91440" marR="91440" marT="45720" marB="45720">
+                    <a:lnL w="12700" cap="flat" cmpd="sng" algn="ctr">
+                      <a:solidFill>
+                        <a:srgbClr val="FFFFFF"/>
+                      </a:solidFill>
+                      <a:prstDash val="solid"/>
+                      <a:round/>
+                      <a:headEnd type="none" w="med" len="med"/>
+                      <a:tailEnd type="none" w="med" len="med"/>
+                    </a:lnL>
+                    <a:lnR w="12700" cap="flat" cmpd="sng" algn="ctr">
+                      <a:solidFill>
+                        <a:srgbClr val="FFFFFF"/>
+                      </a:solidFill>
+                      <a:prstDash val="solid"/>
+                      <a:round/>
+                      <a:headEnd type="none" w="med" len="med"/>
+                      <a:tailEnd type="none" w="med" len="med"/>
+                    </a:lnR>
+                    <a:lnT w="12700" cap="flat" cmpd="sng" algn="ctr">
+                      <a:solidFill>
+                        <a:srgbClr val="FFFFFF"/>
+                      </a:solidFill>
+                      <a:prstDash val="solid"/>
+                      <a:round/>
+                      <a:headEnd type="none" w="med" len="med"/>
+                      <a:tailEnd type="none" w="med" len="med"/>
+                    </a:lnT>
+                    <a:lnB w="12700" cap="flat" cmpd="sng" algn="ctr">
+                      <a:solidFill>
+                        <a:srgbClr val="FFFFFF"/>
+                      </a:solidFill>
+                      <a:prstDash val="solid"/>
+                      <a:round/>
+                      <a:headEnd type="none" w="med" len="med"/>
+                      <a:tailEnd type="none" w="med" len="med"/>
+                    </a:lnB>
+                  </a:tcPr>
+                </a:tc>
+                <a:tc>
+                  <a:txBody>
+                    <a:bodyPr/>
+                    <a:lstStyle/>
+                    <a:p>
+                      <a:pPr algn="r" indent="0" marL="0">
+                        <a:buNone/>
+                      </a:pPr>
+                      <a:r>
+                        <a:rPr lang="en-US" sz="1250" dirty="0">
+                          <a:solidFill>
+                            <a:srgbClr val="000000"/>
+                          </a:solidFill>
+                          <a:latin typeface="Arial" pitchFamily="34" charset="0"/>
+                          <a:ea typeface="Arial" pitchFamily="34" charset="-122"/>
+                          <a:cs typeface="Arial" pitchFamily="34" charset="-120"/>
+                        </a:rPr>
+                        <a:t>153.188 €</a:t>
+                      </a:r>
+                      <a:endParaRPr lang="en-US" sz="1250" dirty="0">
+                        <a:latin typeface="Arial" charset="0"/>
+                        <a:ea typeface="Arial" charset="0"/>
+                        <a:cs typeface="Arial" charset="0"/>
+                      </a:endParaRPr>
+                    </a:p>
+                  </a:txBody>
+                  <a:tcPr marL="91440" marR="91440" marT="45720" marB="45720">
+                    <a:lnL w="12700" cap="flat" cmpd="sng" algn="ctr">
+                      <a:solidFill>
+                        <a:srgbClr val="FFFFFF"/>
+                      </a:solidFill>
+                      <a:prstDash val="solid"/>
+                      <a:round/>
+                      <a:headEnd type="none" w="med" len="med"/>
+                      <a:tailEnd type="none" w="med" len="med"/>
+                    </a:lnL>
+                    <a:lnR w="12700" cap="flat" cmpd="sng" algn="ctr">
+                      <a:solidFill>
+                        <a:srgbClr val="FFFFFF"/>
+                      </a:solidFill>
+                      <a:prstDash val="solid"/>
+                      <a:round/>
+                      <a:headEnd type="none" w="med" len="med"/>
+                      <a:tailEnd type="none" w="med" len="med"/>
+                    </a:lnR>
+                    <a:lnT w="12700" cap="flat" cmpd="sng" algn="ctr">
+                      <a:solidFill>
+                        <a:srgbClr val="FFFFFF"/>
+                      </a:solidFill>
+                      <a:prstDash val="solid"/>
+                      <a:round/>
+                      <a:headEnd type="none" w="med" len="med"/>
+                      <a:tailEnd type="none" w="med" len="med"/>
+                    </a:lnT>
+                    <a:lnB w="12700" cap="flat" cmpd="sng" algn="ctr">
+                      <a:solidFill>
+                        <a:srgbClr val="FFFFFF"/>
+                      </a:solidFill>
+                      <a:prstDash val="solid"/>
+                      <a:round/>
+                      <a:headEnd type="none" w="med" len="med"/>
+                      <a:tailEnd type="none" w="med" len="med"/>
+                    </a:lnB>
+                  </a:tcPr>
+                </a:tc>
+              </a:tr>
+            </a:tbl>
+          </a:graphicData>
+        </a:graphic>
+      </p:graphicFrame>
+      <p:sp>
+        <p:nvSpPr>
+          <p:cNvPr id="6" name="Text 2"/>
+          <p:cNvSpPr txBox="1"/>
+          <p:nvPr/>
+        </p:nvSpPr>
+        <p:spPr>
+          <a:xfrm>
+            <a:off x="548640" y="4023360"/>
+            <a:ext cx="11091672" cy="1645920"/>
+          </a:xfrm>
+          <a:prstGeom prst="rect">
+            <a:avLst/>
+          </a:prstGeom>
+          <a:noFill/>
+          <a:ln/>
+        </p:spPr>
+        <p:txBody>
+          <a:bodyPr wrap="square" lIns="0" tIns="0" rIns="0" bIns="0" rtlCol="0" anchor="t"/>
+          <a:lstStyle/>
+          <a:p>
+            <a:pPr indent="0" marL="0">
+              <a:spcAft>
+                <a:spcPts val="800"/>
+              </a:spcAft>
+              <a:buNone/>
+            </a:pPr>
+            <a:r>
+              <a:rPr lang="en-US" sz="1400" dirty="0">
+                <a:solidFill>
+                  <a:schemeClr val="tx1"/>
+                </a:solidFill>
+                <a:latin typeface="Arial" pitchFamily="34" charset="0"/>
+                <a:ea typeface="Arial" pitchFamily="34" charset="-122"/>
+                <a:cs typeface="Arial" pitchFamily="34" charset="-120"/>
+              </a:rPr>
+              <a:t>Bei Selbstkostenpreis ist jede Einheit im Minus. Für ein Plus von 250 € müsste der Preis so tief sinken, dass du insgesamt 1.197.594 € Differenz trägst.</a:t>
+            </a:r>
+            <a:endParaRPr lang="en-US" sz="1400" dirty="0"/>
+          </a:p>
+          <a:p>
+            <a:pPr indent="0" marL="0">
+              <a:spcAft>
+                <a:spcPts val="800"/>
+              </a:spcAft>
+              <a:buNone/>
+            </a:pPr>
+            <a:r>
+              <a:rPr lang="en-US" sz="1400" dirty="0">
+                <a:solidFill>
+                  <a:schemeClr val="tx1"/>
+                </a:solidFill>
+                <a:latin typeface="Arial" pitchFamily="34" charset="0"/>
+                <a:ea typeface="Arial" pitchFamily="34" charset="-122"/>
+                <a:cs typeface="Arial" pitchFamily="34" charset="-120"/>
+              </a:rPr>
+              <a:t>Dein Ergebnis dann: Gastro 15.250 € minus Rate EG 4.176 € minus Zinsen auf die Differenz 3.500 € = +7.573 € pro Monat. Eine Bank finanziert eine so hohe Differenz kaum.</a:t>
+            </a:r>
+            <a:endParaRPr lang="en-US" sz="1400" dirty="0"/>
+          </a:p>
+        </p:txBody>
+      </p:sp>
+      <p:sp>
+        <p:nvSpPr>
+          <p:cNvPr id="25" name="Slide Number Placeholder 0"/>
+          <p:cNvSpPr>
+            <a:spLocks noGrp="1"/>
+          </p:cNvSpPr>
+          <p:nvPr>
+            <p:ph type="sldNum" sz="quarter" idx="4294967295"/>
+          </p:nvPr>
+        </p:nvSpPr>
+        <p:spPr>
+          <a:xfrm>
+            <a:off x="11183112" y="6446520"/>
+            <a:ext cx="548640" cy="274320"/>
+          </a:xfrm>
+          <a:prstGeom prst="rect">
+            <a:avLst/>
+          </a:prstGeom>
+          <a:extLst>
+            <a:ext uri="{C572A759-6A51-4108-AA02-DFA0A04FC94B}">
+              <ma14:wrappingTextBoxFlag xmlns:ma14="http://schemas.microsoft.com/office/mac/drawingml/2011/main" val="0"/>
+            </a:ext>
+          </a:extLst>
+        </p:spPr>
+        <p:txBody>
+          <a:bodyPr/>
+          <a:lstStyle>
+            <a:lvl1pPr>
+              <a:defRPr sz="1000">
+                <a:solidFill>
+                  <a:schemeClr val="accent4"/>
+                </a:solidFill>
+              </a:defRPr>
+            </a:lvl1pPr>
+          </a:lstStyle>
+          <a:p>
+            <a:pPr algn="r"/>
+            <a:fld id="{F7021451-1387-4CA6-816F-3879F97B5CBC}" type="slidenum">
+              <a:rPr b="0" lang="en-US"/>
+              <a:t>7</a:t>
+            </a:fld>
+            <a:endParaRPr lang="en-US"/>
+          </a:p>
+        </p:txBody>
+      </p:sp>
+    </p:spTree>
+  </p:cSld>
+  <p:clrMapOvr>
+    <a:masterClrMapping/>
+  </p:clrMapOvr>
+</p:sld>
+</file>
+
+<file path=ppt/slides/slide8.xml><?xml version="1.0" encoding="utf-8"?>
+<p:sld xmlns:a="http://schemas.openxmlformats.org/drawingml/2006/main" xmlns:r="http://schemas.openxmlformats.org/officeDocument/2006/relationships" xmlns:p="http://schemas.openxmlformats.org/presentationml/2006/main">
+  <p:cSld name="Slide 8">
+    <p:spTree>
+      <p:nvGrpSpPr>
+        <p:cNvPr id="1" name=""/>
+        <p:cNvGrpSpPr/>
+        <p:nvPr/>
+      </p:nvGrpSpPr>
+      <p:grpSpPr>
+        <a:xfrm>
+          <a:off x="0" y="0"/>
+          <a:ext cx="0" cy="0"/>
+          <a:chOff x="0" y="0"/>
+          <a:chExt cx="0" cy="0"/>
+        </a:xfrm>
+      </p:grpSpPr>
+      <p:sp>
+        <p:nvSpPr>
+          <p:cNvPr id="2" name="Text 1"/>
+          <p:cNvSpPr/>
+          <p:nvPr>
+            <p:ph idx="101" type="title" hasCustomPrompt="1"/>
+          </p:nvPr>
+        </p:nvSpPr>
+        <p:spPr>
+          <a:xfrm>
+            <a:off x="548640" y="320040"/>
+            <a:ext cx="11091672" cy="822960"/>
+          </a:xfrm>
+          <a:prstGeom prst="rect">
+            <a:avLst/>
+          </a:prstGeom>
+          <a:noFill/>
+          <a:ln/>
+        </p:spPr>
+        <p:txBody>
+          <a:bodyPr wrap="square" lIns="0" tIns="0" rIns="0" bIns="0" rtlCol="0" anchor="ctr"/>
+          <a:lstStyle/>
+          <a:p>
+            <a:pPr algn="l" indent="0" marL="0">
+              <a:buNone/>
+            </a:pPr>
+            <a:r>
+              <a:rPr lang="en-US" sz="2700" dirty="0">
+                <a:solidFill>
+                  <a:schemeClr val="accent1"/>
+                </a:solidFill>
+                <a:latin typeface="Georgia" pitchFamily="34" charset="0"/>
+                <a:ea typeface="Georgia" pitchFamily="34" charset="-122"/>
+                <a:cs typeface="Georgia" pitchFamily="34" charset="-120"/>
+              </a:rPr>
               <a:t>Recht und Risiken</a:t>
             </a:r>
             <a:endParaRPr lang="en-US" sz="2700" dirty="0"/>
@@ -10901,7 +12831,7 @@
             <a:pPr algn="r"/>
             <a:fld id="{F7021451-1387-4CA6-816F-3879F97B5CBC}" type="slidenum">
               <a:rPr b="0" lang="en-US"/>
-              <a:t>7</a:t>
+              <a:t>8</a:t>
             </a:fld>
             <a:endParaRPr lang="en-US"/>
           </a:p>
@@ -10915,9 +12845,9 @@
 </p:sld>
 </file>
 
-<file path=ppt/slides/slide8.xml><?xml version="1.0" encoding="utf-8"?>
+<file path=ppt/slides/slide9.xml><?xml version="1.0" encoding="utf-8"?>
 <p:sld xmlns:a="http://schemas.openxmlformats.org/drawingml/2006/main" xmlns:r="http://schemas.openxmlformats.org/officeDocument/2006/relationships" xmlns:p="http://schemas.openxmlformats.org/presentationml/2006/main">
-  <p:cSld name="Slide 8">
+  <p:cSld name="Slide 9">
     <p:spTree>
       <p:nvGrpSpPr>
         <p:cNvPr id="1" name=""/>
@@ -11213,7 +13143,7 @@
             <a:pPr algn="r"/>
             <a:fld id="{F7021451-1387-4CA6-816F-3879F97B5CBC}" type="slidenum">
               <a:rPr b="0" lang="en-US"/>
-              <a:t>8</a:t>
+              <a:t>9</a:t>
             </a:fld>
             <a:endParaRPr lang="en-US"/>
           </a:p>

</xml_diff>

<commit_message>
Staffelgeschoss 280 m² Holzbau, Terrasse nur 0,8 m Umlauf (58 m²), neue KI-Bilder ohne Gartenmöbel
Co-Authored-By: Claude Sonnet 5.5 <noreply@anthropic.com>
Claude-Session: https://claude.ai/code/session_01HJGZfxHv7bzYyqdLwg8aFJ
</commit_message>
<xml_diff>
--- a/praesentation/Neue-Mitte-Werlte_Baufeld3_Airbnb-Apartments.pptx
+++ b/praesentation/Neue-Mitte-Werlte_Baufeld3_Airbnb-Apartments.pptx
@@ -598,7 +598,7 @@
           <a:p>
             <a:r>
               <a:rPr lang="en-US" dirty="0"/>
-              <a:t>Variante A: 930 m² BGF, EG Gastro 290 m², darüber 6 möblierte Apartments, Staffel in Holzbau.</a:t>
+              <a:t>Variante A: 960 m² BGF, EG Gastro 290 m², darüber 6 möblierte Apartments, Staffel in Holzbau.</a:t>
             </a:r>
             <a:endParaRPr lang="en-US" dirty="0"/>
           </a:p>
@@ -2121,7 +2121,7 @@
       </p:sp>
       <p:sp>
         <p:nvSpPr>
-          <p:cNvPr id="5" name="Kennzahl Apartments: 3 × 85 m² (4 Gäste), 3 × 56 m² (2 Gäste)"/>
+          <p:cNvPr id="5" name="Kennzahl Apartments: 3 × 85 m² (4 Gäste), 3 × 63 m² (2 Gäste)"/>
           <p:cNvSpPr/>
           <p:nvPr/>
         </p:nvSpPr>
@@ -2218,7 +2218,7 @@
                 <a:ea typeface="Arial" pitchFamily="34" charset="-122"/>
                 <a:cs typeface="Arial" pitchFamily="34" charset="-120"/>
               </a:rPr>
-              <a:t>Apartments: 3 × 85 m² (4 Gäste), 3 × 56 m² (2 Gäste)</a:t>
+              <a:t>Apartments: 3 × 85 m² (4 Gäste), 3 × 63 m² (2 Gäste)</a:t>
             </a:r>
             <a:endParaRPr lang="en-US" sz="1300" dirty="0"/>
           </a:p>
@@ -2284,7 +2284,7 @@
                 <a:ea typeface="Georgia" pitchFamily="34" charset="-122"/>
                 <a:cs typeface="Georgia" pitchFamily="34" charset="-120"/>
               </a:rPr>
-              <a:t>253.800 €</a:t>
+              <a:t>266.400 €</a:t>
             </a:r>
             <a:endParaRPr lang="en-US" sz="2800" dirty="0"/>
           </a:p>
@@ -2389,7 +2389,7 @@
                 <a:ea typeface="Georgia" pitchFamily="34" charset="-122"/>
                 <a:cs typeface="Georgia" pitchFamily="34" charset="-120"/>
               </a:rPr>
-              <a:t>+7.107 €</a:t>
+              <a:t>+6.886 €</a:t>
             </a:r>
             <a:endParaRPr lang="en-US" sz="2800" dirty="0"/>
           </a:p>
@@ -2494,7 +2494,7 @@
                 <a:ea typeface="Georgia" pitchFamily="34" charset="-122"/>
                 <a:cs typeface="Georgia" pitchFamily="34" charset="-120"/>
               </a:rPr>
-              <a:t>+9.860 €</a:t>
+              <a:t>+9.687 €</a:t>
             </a:r>
             <a:endParaRPr lang="en-US" sz="2800" dirty="0"/>
           </a:p>
@@ -2595,7 +2595,7 @@
                 <a:ea typeface="Arial" pitchFamily="34" charset="-122"/>
                 <a:cs typeface="Arial" pitchFamily="34" charset="-120"/>
               </a:rPr>
-              <a:t>Bei 45 % Auslastung und 100 € bzw. 85 € pro Nacht liegt das Ergebnis des Hauses 2.753 € unter der Dauermiete. Erst bei ca. 82 % Auslastung wäre es gleich.</a:t>
+              <a:t>Bei 45 % Auslastung und 100 € bzw. 85 € pro Nacht liegt das Ergebnis des Hauses 2.801 € unter der Dauermiete. Erst bei ca. 82 % Auslastung wäre es gleich.</a:t>
             </a:r>
             <a:endParaRPr lang="en-US" sz="1500" dirty="0"/>
           </a:p>
@@ -3852,7 +3852,7 @@
                           <a:ea typeface="Arial" pitchFamily="34" charset="-122"/>
                           <a:cs typeface="Arial" pitchFamily="34" charset="-120"/>
                         </a:rPr>
-                        <a:t>100 € (85 m²), 85 € (56 m²), 45 %</a:t>
+                        <a:t>100 € (85 m²), 85 € (63 m²), 45 %</a:t>
                       </a:r>
                       <a:endParaRPr lang="en-US" sz="1250" dirty="0">
                         <a:latin typeface="Arial" charset="0"/>
@@ -5457,7 +5457,7 @@
                 <a:ea typeface="Arial" pitchFamily="34" charset="-122"/>
                 <a:cs typeface="Arial" pitchFamily="34" charset="-120"/>
               </a:rPr>
-              <a:t>ca. 600 € je m² (Möbel, Küche, Wäsche, Technik) bei 423 m², das sind 253.800 € mehr im Kredit.</a:t>
+              <a:t>ca. 600 € je m² (Möbel, Küche, Wäsche, Technik) bei 444 m², das sind 266.400 € mehr im Kredit.</a:t>
             </a:r>
             <a:endParaRPr lang="en-US" sz="1300" dirty="0"/>
           </a:p>
@@ -6314,7 +6314,7 @@
                           <a:ea typeface="Arial" pitchFamily="34" charset="-122"/>
                           <a:cs typeface="Arial" pitchFamily="34" charset="-120"/>
                         </a:rPr>
-                        <a:t>11.137 €</a:t>
+                        <a:t>11.358 €</a:t>
                       </a:r>
                       <a:endParaRPr lang="en-US" sz="1250" dirty="0">
                         <a:latin typeface="Arial" charset="0"/>
@@ -6379,7 +6379,7 @@
                           <a:ea typeface="Arial" pitchFamily="34" charset="-122"/>
                           <a:cs typeface="Arial" pitchFamily="34" charset="-120"/>
                         </a:rPr>
-                        <a:t>+6.365 €</a:t>
+                        <a:t>+6.143 €</a:t>
                       </a:r>
                       <a:endParaRPr lang="en-US" sz="1250" dirty="0">
                         <a:latin typeface="Arial" charset="0"/>
@@ -6447,7 +6447,7 @@
                           <a:ea typeface="Arial" pitchFamily="34" charset="-122"/>
                           <a:cs typeface="Arial" pitchFamily="34" charset="-120"/>
                         </a:rPr>
-                        <a:t>−3.496 €</a:t>
+                        <a:t>−3.544 €</a:t>
                       </a:r>
                       <a:endParaRPr lang="en-US" sz="1250" dirty="0">
                         <a:latin typeface="Arial" charset="0"/>
@@ -6709,7 +6709,7 @@
                           <a:ea typeface="Arial" pitchFamily="34" charset="-122"/>
                           <a:cs typeface="Arial" pitchFamily="34" charset="-120"/>
                         </a:rPr>
-                        <a:t>11.137 €</a:t>
+                        <a:t>11.358 €</a:t>
                       </a:r>
                       <a:endParaRPr lang="en-US" sz="1250" dirty="0">
                         <a:latin typeface="Arial" charset="0"/>
@@ -6774,7 +6774,7 @@
                           <a:ea typeface="Arial" pitchFamily="34" charset="-122"/>
                           <a:cs typeface="Arial" pitchFamily="34" charset="-120"/>
                         </a:rPr>
-                        <a:t>+7.107 €</a:t>
+                        <a:t>+6.886 €</a:t>
                       </a:r>
                       <a:endParaRPr lang="en-US" sz="1250" dirty="0">
                         <a:latin typeface="Arial" charset="0"/>
@@ -6842,7 +6842,7 @@
                           <a:ea typeface="Arial" pitchFamily="34" charset="-122"/>
                           <a:cs typeface="Arial" pitchFamily="34" charset="-120"/>
                         </a:rPr>
-                        <a:t>−2.753 €</a:t>
+                        <a:t>−2.801 €</a:t>
                       </a:r>
                       <a:endParaRPr lang="en-US" sz="1250" dirty="0">
                         <a:latin typeface="Arial" charset="0"/>
@@ -7104,7 +7104,7 @@
                           <a:ea typeface="Arial" pitchFamily="34" charset="-122"/>
                           <a:cs typeface="Arial" pitchFamily="34" charset="-120"/>
                         </a:rPr>
-                        <a:t>11.137 €</a:t>
+                        <a:t>11.358 €</a:t>
                       </a:r>
                       <a:endParaRPr lang="en-US" sz="1250" dirty="0">
                         <a:latin typeface="Arial" charset="0"/>
@@ -7169,7 +7169,7 @@
                           <a:ea typeface="Arial" pitchFamily="34" charset="-122"/>
                           <a:cs typeface="Arial" pitchFamily="34" charset="-120"/>
                         </a:rPr>
-                        <a:t>+7.850 €</a:t>
+                        <a:t>+7.629 €</a:t>
                       </a:r>
                       <a:endParaRPr lang="en-US" sz="1250" dirty="0">
                         <a:latin typeface="Arial" charset="0"/>
@@ -7237,7 +7237,7 @@
                           <a:ea typeface="Arial" pitchFamily="34" charset="-122"/>
                           <a:cs typeface="Arial" pitchFamily="34" charset="-120"/>
                         </a:rPr>
-                        <a:t>−2.010 €</a:t>
+                        <a:t>−2.058 €</a:t>
                       </a:r>
                       <a:endParaRPr lang="en-US" sz="1250" dirty="0">
                         <a:latin typeface="Arial" charset="0"/>
@@ -7499,7 +7499,7 @@
                           <a:ea typeface="Arial" pitchFamily="34" charset="-122"/>
                           <a:cs typeface="Arial" pitchFamily="34" charset="-120"/>
                         </a:rPr>
-                        <a:t>11.137 €</a:t>
+                        <a:t>11.358 €</a:t>
                       </a:r>
                       <a:endParaRPr lang="en-US" sz="1250" dirty="0">
                         <a:latin typeface="Arial" charset="0"/>
@@ -7564,7 +7564,7 @@
                           <a:ea typeface="Arial" pitchFamily="34" charset="-122"/>
                           <a:cs typeface="Arial" pitchFamily="34" charset="-120"/>
                         </a:rPr>
-                        <a:t>+8.593 €</a:t>
+                        <a:t>+8.372 €</a:t>
                       </a:r>
                       <a:endParaRPr lang="en-US" sz="1250" dirty="0">
                         <a:latin typeface="Arial" charset="0"/>
@@ -7632,7 +7632,7 @@
                           <a:ea typeface="Arial" pitchFamily="34" charset="-122"/>
                           <a:cs typeface="Arial" pitchFamily="34" charset="-120"/>
                         </a:rPr>
-                        <a:t>−1.267 €</a:t>
+                        <a:t>−1.315 €</a:t>
                       </a:r>
                       <a:endParaRPr lang="en-US" sz="1250" dirty="0">
                         <a:latin typeface="Arial" charset="0"/>
@@ -7894,7 +7894,7 @@
                           <a:ea typeface="Arial" pitchFamily="34" charset="-122"/>
                           <a:cs typeface="Arial" pitchFamily="34" charset="-120"/>
                         </a:rPr>
-                        <a:t>11.137 €</a:t>
+                        <a:t>11.358 €</a:t>
                       </a:r>
                       <a:endParaRPr lang="en-US" sz="1250" dirty="0">
                         <a:latin typeface="Arial" charset="0"/>
@@ -7959,7 +7959,7 @@
                           <a:ea typeface="Arial" pitchFamily="34" charset="-122"/>
                           <a:cs typeface="Arial" pitchFamily="34" charset="-120"/>
                         </a:rPr>
-                        <a:t>+9.336 €</a:t>
+                        <a:t>+9.114 €</a:t>
                       </a:r>
                       <a:endParaRPr lang="en-US" sz="1250" dirty="0">
                         <a:latin typeface="Arial" charset="0"/>
@@ -8027,7 +8027,7 @@
                           <a:ea typeface="Arial" pitchFamily="34" charset="-122"/>
                           <a:cs typeface="Arial" pitchFamily="34" charset="-120"/>
                         </a:rPr>
-                        <a:t>−525 €</a:t>
+                        <a:t>−572 €</a:t>
                       </a:r>
                       <a:endParaRPr lang="en-US" sz="1250" dirty="0">
                         <a:latin typeface="Arial" charset="0"/>
@@ -8289,7 +8289,7 @@
                           <a:ea typeface="Arial" pitchFamily="34" charset="-122"/>
                           <a:cs typeface="Arial" pitchFamily="34" charset="-120"/>
                         </a:rPr>
-                        <a:t>10.172 €</a:t>
+                        <a:t>10.345 €</a:t>
                       </a:r>
                       <a:endParaRPr lang="en-US" sz="1250" dirty="0">
                         <a:latin typeface="Arial" charset="0"/>
@@ -8354,7 +8354,7 @@
                           <a:ea typeface="Arial" pitchFamily="34" charset="-122"/>
                           <a:cs typeface="Arial" pitchFamily="34" charset="-120"/>
                         </a:rPr>
-                        <a:t>+9.860 €</a:t>
+                        <a:t>+9.687 €</a:t>
                       </a:r>
                       <a:endParaRPr lang="en-US" sz="1250" dirty="0">
                         <a:latin typeface="Arial" charset="0"/>
@@ -8497,7 +8497,7 @@
                 <a:ea typeface="Arial" pitchFamily="34" charset="-122"/>
                 <a:cs typeface="Arial" pitchFamily="34" charset="-120"/>
               </a:rPr>
-              <a:t>Ohne Einrichtungskosten läge die Rate bei 10.172 €. Mit der Möblierung steigt sie auf 11.137 €.</a:t>
+              <a:t>Ohne Einrichtungskosten läge die Rate bei 10.345 €. Mit der Möblierung steigt sie auf 11.358 €.</a:t>
             </a:r>
             <a:endParaRPr lang="en-US" sz="1300" dirty="0"/>
           </a:p>
@@ -8833,7 +8833,7 @@
                           <a:ea typeface="Arial" pitchFamily="34" charset="-122"/>
                           <a:cs typeface="Arial" pitchFamily="34" charset="-120"/>
                         </a:rPr>
-                        <a:t>56 m², 2 Gäste</a:t>
+                        <a:t>63 m², 2 Gäste</a:t>
                       </a:r>
                       <a:endParaRPr lang="en-US" sz="1250" dirty="0">
                         <a:latin typeface="Arial" charset="0"/>
@@ -9234,7 +9234,7 @@
                           <a:ea typeface="Arial" pitchFamily="34" charset="-122"/>
                           <a:cs typeface="Arial" pitchFamily="34" charset="-120"/>
                         </a:rPr>
-                        <a:t>+6.439 €</a:t>
+                        <a:t>+6.218 €</a:t>
                       </a:r>
                       <a:endParaRPr lang="en-US" sz="1250" dirty="0">
                         <a:latin typeface="Arial" charset="0"/>
@@ -9302,7 +9302,7 @@
                           <a:ea typeface="Arial" pitchFamily="34" charset="-122"/>
                           <a:cs typeface="Arial" pitchFamily="34" charset="-120"/>
                         </a:rPr>
-                        <a:t>−3.421 €</a:t>
+                        <a:t>−3.469 €</a:t>
                       </a:r>
                       <a:endParaRPr lang="en-US" sz="1250" dirty="0">
                         <a:latin typeface="Arial" charset="0"/>
@@ -9564,7 +9564,7 @@
                           <a:ea typeface="Arial" pitchFamily="34" charset="-122"/>
                           <a:cs typeface="Arial" pitchFamily="34" charset="-120"/>
                         </a:rPr>
-                        <a:t>+7.107 €</a:t>
+                        <a:t>+6.886 €</a:t>
                       </a:r>
                       <a:endParaRPr lang="en-US" sz="1250" dirty="0">
                         <a:latin typeface="Arial" charset="0"/>
@@ -9632,7 +9632,7 @@
                           <a:ea typeface="Arial" pitchFamily="34" charset="-122"/>
                           <a:cs typeface="Arial" pitchFamily="34" charset="-120"/>
                         </a:rPr>
-                        <a:t>−2.753 €</a:t>
+                        <a:t>−2.801 €</a:t>
                       </a:r>
                       <a:endParaRPr lang="en-US" sz="1250" dirty="0">
                         <a:latin typeface="Arial" charset="0"/>
@@ -9894,7 +9894,7 @@
                           <a:ea typeface="Arial" pitchFamily="34" charset="-122"/>
                           <a:cs typeface="Arial" pitchFamily="34" charset="-120"/>
                         </a:rPr>
-                        <a:t>+7.776 €</a:t>
+                        <a:t>+7.555 €</a:t>
                       </a:r>
                       <a:endParaRPr lang="en-US" sz="1250" dirty="0">
                         <a:latin typeface="Arial" charset="0"/>
@@ -9962,7 +9962,7 @@
                           <a:ea typeface="Arial" pitchFamily="34" charset="-122"/>
                           <a:cs typeface="Arial" pitchFamily="34" charset="-120"/>
                         </a:rPr>
-                        <a:t>−2.084 €</a:t>
+                        <a:t>−2.132 €</a:t>
                       </a:r>
                       <a:endParaRPr lang="en-US" sz="1250" dirty="0">
                         <a:latin typeface="Arial" charset="0"/>
@@ -10224,7 +10224,7 @@
                           <a:ea typeface="Arial" pitchFamily="34" charset="-122"/>
                           <a:cs typeface="Arial" pitchFamily="34" charset="-120"/>
                         </a:rPr>
-                        <a:t>+8.444 €</a:t>
+                        <a:t>+8.223 €</a:t>
                       </a:r>
                       <a:endParaRPr lang="en-US" sz="1250" dirty="0">
                         <a:latin typeface="Arial" charset="0"/>
@@ -10292,7 +10292,7 @@
                           <a:ea typeface="Arial" pitchFamily="34" charset="-122"/>
                           <a:cs typeface="Arial" pitchFamily="34" charset="-120"/>
                         </a:rPr>
-                        <a:t>−1.416 €</a:t>
+                        <a:t>−1.464 €</a:t>
                       </a:r>
                       <a:endParaRPr lang="en-US" sz="1250" dirty="0">
                         <a:latin typeface="Arial" charset="0"/>
@@ -11257,7 +11257,7 @@
                           <a:ea typeface="Arial" pitchFamily="34" charset="-122"/>
                           <a:cs typeface="Arial" pitchFamily="34" charset="-120"/>
                         </a:rPr>
-                        <a:t>366.524 €</a:t>
+                        <a:t>365.625 €</a:t>
                       </a:r>
                       <a:endParaRPr lang="en-US" sz="1250" dirty="0">
                         <a:latin typeface="Arial" charset="0"/>
@@ -11322,7 +11322,7 @@
                           <a:ea typeface="Arial" pitchFamily="34" charset="-122"/>
                           <a:cs typeface="Arial" pitchFamily="34" charset="-120"/>
                         </a:rPr>
-                        <a:t>1.396 €</a:t>
+                        <a:t>1.392 €</a:t>
                       </a:r>
                       <a:endParaRPr lang="en-US" sz="1250" dirty="0">
                         <a:latin typeface="Arial" charset="0"/>
@@ -11452,7 +11452,7 @@
                           <a:ea typeface="Arial" pitchFamily="34" charset="-122"/>
                           <a:cs typeface="Arial" pitchFamily="34" charset="-120"/>
                         </a:rPr>
-                        <a:t>−794 €</a:t>
+                        <a:t>−790 €</a:t>
                       </a:r>
                       <a:endParaRPr lang="en-US" sz="1250" dirty="0">
                         <a:latin typeface="Arial" charset="0"/>
@@ -11520,7 +11520,7 @@
                           <a:ea typeface="Arial" pitchFamily="34" charset="-122"/>
                           <a:cs typeface="Arial" pitchFamily="34" charset="-120"/>
                         </a:rPr>
-                        <a:t>120.514 €</a:t>
+                        <a:t>120.517 €</a:t>
                       </a:r>
                       <a:endParaRPr lang="en-US" sz="1250" dirty="0">
                         <a:latin typeface="Arial" charset="0"/>
@@ -11585,7 +11585,7 @@
                           <a:ea typeface="Arial" pitchFamily="34" charset="-122"/>
                           <a:cs typeface="Arial" pitchFamily="34" charset="-120"/>
                         </a:rPr>
-                        <a:t>246.010 €</a:t>
+                        <a:t>245.108 €</a:t>
                       </a:r>
                       <a:endParaRPr lang="en-US" sz="1250" dirty="0">
                         <a:latin typeface="Arial" charset="0"/>
@@ -11652,7 +11652,7 @@
                           <a:ea typeface="Arial" pitchFamily="34" charset="-122"/>
                           <a:cs typeface="Arial" pitchFamily="34" charset="-120"/>
                         </a:rPr>
-                        <a:t>56 m²</a:t>
+                        <a:t>63 m²</a:t>
                       </a:r>
                       <a:endParaRPr lang="en-US" sz="1250" dirty="0">
                         <a:latin typeface="Arial" charset="0"/>
@@ -11782,7 +11782,7 @@
                           <a:ea typeface="Arial" pitchFamily="34" charset="-122"/>
                           <a:cs typeface="Arial" pitchFamily="34" charset="-120"/>
                         </a:rPr>
-                        <a:t>242.795 €</a:t>
+                        <a:t>263.974 €</a:t>
                       </a:r>
                       <a:endParaRPr lang="en-US" sz="1250" dirty="0">
                         <a:latin typeface="Arial" charset="0"/>
@@ -11847,7 +11847,7 @@
                           <a:ea typeface="Arial" pitchFamily="34" charset="-122"/>
                           <a:cs typeface="Arial" pitchFamily="34" charset="-120"/>
                         </a:rPr>
-                        <a:t>925 €</a:t>
+                        <a:t>1.005 €</a:t>
                       </a:r>
                       <a:endParaRPr lang="en-US" sz="1250" dirty="0">
                         <a:latin typeface="Arial" charset="0"/>
@@ -11977,7 +11977,7 @@
                           <a:ea typeface="Arial" pitchFamily="34" charset="-122"/>
                           <a:cs typeface="Arial" pitchFamily="34" charset="-120"/>
                         </a:rPr>
-                        <a:t>−413 €</a:t>
+                        <a:t>−493 €</a:t>
                       </a:r>
                       <a:endParaRPr lang="en-US" sz="1250" dirty="0">
                         <a:latin typeface="Arial" charset="0"/>
@@ -12045,7 +12045,7 @@
                           <a:ea typeface="Arial" pitchFamily="34" charset="-122"/>
                           <a:cs typeface="Arial" pitchFamily="34" charset="-120"/>
                         </a:rPr>
-                        <a:t>89.607 €</a:t>
+                        <a:t>89.609 €</a:t>
                       </a:r>
                       <a:endParaRPr lang="en-US" sz="1250" dirty="0">
                         <a:latin typeface="Arial" charset="0"/>
@@ -12110,7 +12110,7 @@
                           <a:ea typeface="Arial" pitchFamily="34" charset="-122"/>
                           <a:cs typeface="Arial" pitchFamily="34" charset="-120"/>
                         </a:rPr>
-                        <a:t>153.188 €</a:t>
+                        <a:t>174.365 €</a:t>
                       </a:r>
                       <a:endParaRPr lang="en-US" sz="1250" dirty="0">
                         <a:latin typeface="Arial" charset="0"/>
@@ -12199,7 +12199,7 @@
                 <a:ea typeface="Arial" pitchFamily="34" charset="-122"/>
                 <a:cs typeface="Arial" pitchFamily="34" charset="-120"/>
               </a:rPr>
-              <a:t>Bei Selbstkostenpreis ist jede Einheit im Minus. Für ein Plus von 250 € müsste der Preis so tief sinken, dass du insgesamt 1.197.594 € Differenz trägst.</a:t>
+              <a:t>Bei Selbstkostenpreis ist jede Einheit im Minus. Für ein Plus von 250 € müsste der Preis so tief sinken, dass du insgesamt 1.258.420 € Differenz trägst.</a:t>
             </a:r>
             <a:endParaRPr lang="en-US" sz="1400" dirty="0"/>
           </a:p>
@@ -12219,7 +12219,7 @@
                 <a:ea typeface="Arial" pitchFamily="34" charset="-122"/>
                 <a:cs typeface="Arial" pitchFamily="34" charset="-120"/>
               </a:rPr>
-              <a:t>Dein Ergebnis dann: Gastro 15.250 € minus Rate EG 4.176 € minus Zinsen auf die Differenz 3.500 € = +7.573 € pro Monat. Eine Bank finanziert eine so hohe Differenz kaum.</a:t>
+              <a:t>Dein Ergebnis dann: Gastro 15.250 € minus Rate EG 4.166 € minus Zinsen auf die Differenz 3.678 € = +7.406 € pro Monat. Eine Bank finanziert eine so hohe Differenz kaum.</a:t>
             </a:r>
             <a:endParaRPr lang="en-US" sz="1400" dirty="0"/>
           </a:p>
@@ -12995,7 +12995,7 @@
                 <a:ea typeface="Arial" pitchFamily="34" charset="-122"/>
                 <a:cs typeface="Arial" pitchFamily="34" charset="-120"/>
               </a:rPr>
-              <a:t>Apartments sind möglich, aber im Plan 2.753 € im Monat schwächer als normale Mieter, bei mehr Arbeit und Risiko.</a:t>
+              <a:t>Apartments sind möglich, aber im Plan 2.801 € im Monat schwächer als normale Mieter, bei mehr Arbeit und Risiko.</a:t>
             </a:r>
             <a:endParaRPr lang="en-US" sz="1600" dirty="0"/>
           </a:p>

</xml_diff>

<commit_message>
Hauptvariante B: 540 m² Grundfläche, 8 Wohnungen, Büro im EG; neue einheitliche KI-Bilder zur Werlter Mitte
Co-Authored-By: Claude Sonnet 5.5 <noreply@anthropic.com>
Claude-Session: https://claude.ai/code/session_01HJGZfxHv7bzYyqdLwg8aFJ
</commit_message>
<xml_diff>
--- a/praesentation/Neue-Mitte-Werlte_Baufeld3_Airbnb-Apartments.pptx
+++ b/praesentation/Neue-Mitte-Werlte_Baufeld3_Airbnb-Apartments.pptx
@@ -11520,7 +11520,7 @@
                           <a:ea typeface="Arial" pitchFamily="34" charset="-122"/>
                           <a:cs typeface="Arial" pitchFamily="34" charset="-120"/>
                         </a:rPr>
-                        <a:t>120.517 €</a:t>
+                        <a:t>120.568 €</a:t>
                       </a:r>
                       <a:endParaRPr lang="en-US" sz="1250" dirty="0">
                         <a:latin typeface="Arial" charset="0"/>
@@ -11585,7 +11585,7 @@
                           <a:ea typeface="Arial" pitchFamily="34" charset="-122"/>
                           <a:cs typeface="Arial" pitchFamily="34" charset="-120"/>
                         </a:rPr>
-                        <a:t>245.108 €</a:t>
+                        <a:t>245.056 €</a:t>
                       </a:r>
                       <a:endParaRPr lang="en-US" sz="1250" dirty="0">
                         <a:latin typeface="Arial" charset="0"/>
@@ -12045,7 +12045,7 @@
                           <a:ea typeface="Arial" pitchFamily="34" charset="-122"/>
                           <a:cs typeface="Arial" pitchFamily="34" charset="-120"/>
                         </a:rPr>
-                        <a:t>89.609 €</a:t>
+                        <a:t>89.648 €</a:t>
                       </a:r>
                       <a:endParaRPr lang="en-US" sz="1250" dirty="0">
                         <a:latin typeface="Arial" charset="0"/>
@@ -12110,7 +12110,7 @@
                           <a:ea typeface="Arial" pitchFamily="34" charset="-122"/>
                           <a:cs typeface="Arial" pitchFamily="34" charset="-120"/>
                         </a:rPr>
-                        <a:t>174.365 €</a:t>
+                        <a:t>174.327 €</a:t>
                       </a:r>
                       <a:endParaRPr lang="en-US" sz="1250" dirty="0">
                         <a:latin typeface="Arial" charset="0"/>
@@ -12199,7 +12199,7 @@
                 <a:ea typeface="Arial" pitchFamily="34" charset="-122"/>
                 <a:cs typeface="Arial" pitchFamily="34" charset="-120"/>
               </a:rPr>
-              <a:t>Bei Selbstkostenpreis ist jede Einheit im Minus. Für ein Plus von 250 € müsste der Preis so tief sinken, dass du insgesamt 1.258.420 € Differenz trägst.</a:t>
+              <a:t>Bei Selbstkostenpreis ist jede Einheit im Minus. Für ein Plus von 250 € müsste der Preis so tief sinken, dass du insgesamt 1.258.149 € Differenz trägst.</a:t>
             </a:r>
             <a:endParaRPr lang="en-US" sz="1400" dirty="0"/>
           </a:p>
@@ -12219,7 +12219,7 @@
                 <a:ea typeface="Arial" pitchFamily="34" charset="-122"/>
                 <a:cs typeface="Arial" pitchFamily="34" charset="-120"/>
               </a:rPr>
-              <a:t>Dein Ergebnis dann: Gastro 15.250 € minus Rate EG 4.166 € minus Zinsen auf die Differenz 3.678 € = +7.406 € pro Monat. Eine Bank finanziert eine so hohe Differenz kaum.</a:t>
+              <a:t>Dein Ergebnis dann: Gastro 15.250 € minus Rate EG 4.164 € minus Zinsen auf die Differenz 3.676 € = +7.410 € pro Monat. Eine Bank finanziert eine so hohe Differenz kaum.</a:t>
             </a:r>
             <a:endParaRPr lang="en-US" sz="1400" dirty="0"/>
           </a:p>

</xml_diff>